<commit_message>
Team decks: add a named, individually-graded slide per member (section 03)
Sections 01/02/04/05 stay team-owned; 03 now has one named slide per roster member marked
'graded individually', so the Activity rubric has something per-student to grade. How-to slide
states the split and points the reflection at the team FigJam lane (not a document).

Co-Authored-By: Claude Fable 5 <noreply@anthropic.com>
</commit_message>
<xml_diff>
--- a/slides/team-decks/Week3-Tue-chezborgar.pptx
+++ b/slides/team-decks/Week3-Tue-chezborgar.pptx
@@ -13,6 +13,9 @@
     <p:sldId id="261" r:id="rId13"/>
     <p:sldId id="262" r:id="rId14"/>
     <p:sldId id="263" r:id="rId15"/>
+    <p:sldId id="264" r:id="rId16"/>
+    <p:sldId id="265" r:id="rId17"/>
+    <p:sldId id="266" r:id="rId18"/>
   </p:sldIdLst>
   <p:sldSz cx="12191695" cy="6858000" type="screen4x3"/>
   <p:notesSz cx="6858000" cy="9144000"/>
@@ -789,7 +792,7 @@
           <a:lstStyle/>
           <a:p>
             <a:r>
-              <a:t>Section header — the team's own slides go after this one.</a:t>
+              <a:t>Emily Tai's individually graded section. Their reflection lives in their own lane on the team FigJam canvas.</a:t>
             </a:r>
           </a:p>
         </p:txBody>
@@ -815,6 +818,216 @@
 </file>
 
 <file path=ppt/notesSlides/notesSlide6.xml><?xml version="1.0" encoding="utf-8"?>
+<p:notes xmlns:a="http://schemas.openxmlformats.org/drawingml/2006/main" xmlns:p="http://schemas.openxmlformats.org/presentationml/2006/main" xmlns:r="http://schemas.openxmlformats.org/officeDocument/2006/relationships">
+  <p:cSld>
+    <p:spTree>
+      <p:nvGrpSpPr>
+        <p:cNvPr id="1" name=""/>
+        <p:cNvGrpSpPr/>
+        <p:nvPr/>
+      </p:nvGrpSpPr>
+      <p:grpSpPr>
+        <a:xfrm>
+          <a:off x="0" y="0"/>
+          <a:ext cx="0" cy="0"/>
+          <a:chOff x="0" y="0"/>
+          <a:chExt cx="0" cy="0"/>
+        </a:xfrm>
+      </p:grpSpPr>
+      <p:sp>
+        <p:nvSpPr>
+          <p:cNvPr id="2" name="Slide Image Placeholder 1"/>
+          <p:cNvSpPr>
+            <a:spLocks noGrp="1"/>
+          </p:cNvSpPr>
+          <p:nvPr>
+            <p:ph type="sldImg" idx="2"/>
+          </p:nvPr>
+        </p:nvSpPr>
+        <p:spPr/>
+      </p:sp>
+      <p:sp>
+        <p:nvSpPr>
+          <p:cNvPr id="3" name="Notes Placeholder 2"/>
+          <p:cNvSpPr>
+            <a:spLocks noGrp="1"/>
+          </p:cNvSpPr>
+          <p:nvPr>
+            <p:ph type="body" idx="3" sz="quarter"/>
+          </p:nvPr>
+        </p:nvSpPr>
+        <p:spPr/>
+        <p:txBody>
+          <a:bodyPr/>
+          <a:lstStyle/>
+          <a:p>
+            <a:r>
+              <a:t>Kylie Cheung's individually graded section. Their reflection lives in their own lane on the team FigJam canvas.</a:t>
+            </a:r>
+          </a:p>
+        </p:txBody>
+      </p:sp>
+      <p:sp>
+        <p:nvSpPr>
+          <p:cNvPr id="4" name="Slide Number Placeholder 3"/>
+          <p:cNvSpPr>
+            <a:spLocks noGrp="1"/>
+          </p:cNvSpPr>
+          <p:nvPr>
+            <p:ph type="sldNum" idx="5" sz="quarter"/>
+          </p:nvPr>
+        </p:nvSpPr>
+        <p:spPr/>
+      </p:sp>
+    </p:spTree>
+  </p:cSld>
+  <p:clrMapOvr>
+    <a:masterClrMapping/>
+  </p:clrMapOvr>
+</p:notes>
+</file>
+
+<file path=ppt/notesSlides/notesSlide7.xml><?xml version="1.0" encoding="utf-8"?>
+<p:notes xmlns:a="http://schemas.openxmlformats.org/drawingml/2006/main" xmlns:p="http://schemas.openxmlformats.org/presentationml/2006/main" xmlns:r="http://schemas.openxmlformats.org/officeDocument/2006/relationships">
+  <p:cSld>
+    <p:spTree>
+      <p:nvGrpSpPr>
+        <p:cNvPr id="1" name=""/>
+        <p:cNvGrpSpPr/>
+        <p:nvPr/>
+      </p:nvGrpSpPr>
+      <p:grpSpPr>
+        <a:xfrm>
+          <a:off x="0" y="0"/>
+          <a:ext cx="0" cy="0"/>
+          <a:chOff x="0" y="0"/>
+          <a:chExt cx="0" cy="0"/>
+        </a:xfrm>
+      </p:grpSpPr>
+      <p:sp>
+        <p:nvSpPr>
+          <p:cNvPr id="2" name="Slide Image Placeholder 1"/>
+          <p:cNvSpPr>
+            <a:spLocks noGrp="1"/>
+          </p:cNvSpPr>
+          <p:nvPr>
+            <p:ph type="sldImg" idx="2"/>
+          </p:nvPr>
+        </p:nvSpPr>
+        <p:spPr/>
+      </p:sp>
+      <p:sp>
+        <p:nvSpPr>
+          <p:cNvPr id="3" name="Notes Placeholder 2"/>
+          <p:cNvSpPr>
+            <a:spLocks noGrp="1"/>
+          </p:cNvSpPr>
+          <p:nvPr>
+            <p:ph type="body" idx="3" sz="quarter"/>
+          </p:nvPr>
+        </p:nvSpPr>
+        <p:spPr/>
+        <p:txBody>
+          <a:bodyPr/>
+          <a:lstStyle/>
+          <a:p>
+            <a:r>
+              <a:t>Aria Sharma's individually graded section. Their reflection lives in their own lane on the team FigJam canvas.</a:t>
+            </a:r>
+          </a:p>
+        </p:txBody>
+      </p:sp>
+      <p:sp>
+        <p:nvSpPr>
+          <p:cNvPr id="4" name="Slide Number Placeholder 3"/>
+          <p:cNvSpPr>
+            <a:spLocks noGrp="1"/>
+          </p:cNvSpPr>
+          <p:nvPr>
+            <p:ph type="sldNum" idx="5" sz="quarter"/>
+          </p:nvPr>
+        </p:nvSpPr>
+        <p:spPr/>
+      </p:sp>
+    </p:spTree>
+  </p:cSld>
+  <p:clrMapOvr>
+    <a:masterClrMapping/>
+  </p:clrMapOvr>
+</p:notes>
+</file>
+
+<file path=ppt/notesSlides/notesSlide8.xml><?xml version="1.0" encoding="utf-8"?>
+<p:notes xmlns:a="http://schemas.openxmlformats.org/drawingml/2006/main" xmlns:p="http://schemas.openxmlformats.org/presentationml/2006/main" xmlns:r="http://schemas.openxmlformats.org/officeDocument/2006/relationships">
+  <p:cSld>
+    <p:spTree>
+      <p:nvGrpSpPr>
+        <p:cNvPr id="1" name=""/>
+        <p:cNvGrpSpPr/>
+        <p:nvPr/>
+      </p:nvGrpSpPr>
+      <p:grpSpPr>
+        <a:xfrm>
+          <a:off x="0" y="0"/>
+          <a:ext cx="0" cy="0"/>
+          <a:chOff x="0" y="0"/>
+          <a:chExt cx="0" cy="0"/>
+        </a:xfrm>
+      </p:grpSpPr>
+      <p:sp>
+        <p:nvSpPr>
+          <p:cNvPr id="2" name="Slide Image Placeholder 1"/>
+          <p:cNvSpPr>
+            <a:spLocks noGrp="1"/>
+          </p:cNvSpPr>
+          <p:nvPr>
+            <p:ph type="sldImg" idx="2"/>
+          </p:nvPr>
+        </p:nvSpPr>
+        <p:spPr/>
+      </p:sp>
+      <p:sp>
+        <p:nvSpPr>
+          <p:cNvPr id="3" name="Notes Placeholder 2"/>
+          <p:cNvSpPr>
+            <a:spLocks noGrp="1"/>
+          </p:cNvSpPr>
+          <p:nvPr>
+            <p:ph type="body" idx="3" sz="quarter"/>
+          </p:nvPr>
+        </p:nvSpPr>
+        <p:spPr/>
+        <p:txBody>
+          <a:bodyPr/>
+          <a:lstStyle/>
+          <a:p>
+            <a:r>
+              <a:t>Section header — the team's own slides go after this one.</a:t>
+            </a:r>
+          </a:p>
+        </p:txBody>
+      </p:sp>
+      <p:sp>
+        <p:nvSpPr>
+          <p:cNvPr id="4" name="Slide Number Placeholder 3"/>
+          <p:cNvSpPr>
+            <a:spLocks noGrp="1"/>
+          </p:cNvSpPr>
+          <p:nvPr>
+            <p:ph type="sldNum" idx="5" sz="quarter"/>
+          </p:nvPr>
+        </p:nvSpPr>
+        <p:spPr/>
+      </p:sp>
+    </p:spTree>
+  </p:cSld>
+  <p:clrMapOvr>
+    <a:masterClrMapping/>
+  </p:clrMapOvr>
+</p:notes>
+</file>
+
+<file path=ppt/notesSlides/notesSlide9.xml><?xml version="1.0" encoding="utf-8"?>
 <p:notes xmlns:a="http://schemas.openxmlformats.org/drawingml/2006/main" xmlns:p="http://schemas.openxmlformats.org/presentationml/2006/main" xmlns:r="http://schemas.openxmlformats.org/officeDocument/2006/relationships">
   <p:cSld>
     <p:spTree>
@@ -4129,6 +4342,679 @@
 </p:sld>
 </file>
 
+<file path=ppt/slides/slide10.xml><?xml version="1.0" encoding="utf-8"?>
+<p:sld xmlns:a="http://schemas.openxmlformats.org/drawingml/2006/main" xmlns:p="http://schemas.openxmlformats.org/presentationml/2006/main" xmlns:r="http://schemas.openxmlformats.org/officeDocument/2006/relationships">
+  <p:cSld>
+    <p:bg>
+      <p:bgPr>
+        <a:solidFill>
+          <a:srgbClr val="0B0E14"/>
+        </a:solidFill>
+        <a:effectLst/>
+      </p:bgPr>
+    </p:bg>
+    <p:spTree>
+      <p:nvGrpSpPr>
+        <p:cNvPr id="1" name=""/>
+        <p:cNvGrpSpPr/>
+        <p:nvPr/>
+      </p:nvGrpSpPr>
+      <p:grpSpPr/>
+      <p:sp>
+        <p:nvSpPr>
+          <p:cNvPr id="2" name="Rectangle 1"/>
+          <p:cNvSpPr/>
+          <p:nvPr/>
+        </p:nvSpPr>
+        <p:spPr>
+          <a:xfrm>
+            <a:off x="0" y="0"/>
+            <a:ext cx="256032" cy="6858000"/>
+          </a:xfrm>
+          <a:prstGeom prst="rect">
+            <a:avLst/>
+          </a:prstGeom>
+          <a:solidFill>
+            <a:srgbClr val="00FF41"/>
+          </a:solidFill>
+          <a:ln>
+            <a:noFill/>
+          </a:ln>
+          <a:effectLst/>
+        </p:spPr>
+        <p:style>
+          <a:lnRef idx="1">
+            <a:schemeClr val="accent1"/>
+          </a:lnRef>
+          <a:fillRef idx="3">
+            <a:schemeClr val="accent1"/>
+          </a:fillRef>
+          <a:effectRef idx="2">
+            <a:schemeClr val="accent1"/>
+          </a:effectRef>
+          <a:fontRef idx="minor">
+            <a:schemeClr val="lt1"/>
+          </a:fontRef>
+        </p:style>
+        <p:txBody>
+          <a:bodyPr rtlCol="0" anchor="ctr"/>
+          <a:lstStyle/>
+          <a:p>
+            <a:pPr algn="ctr"/>
+          </a:p>
+        </p:txBody>
+      </p:sp>
+      <p:sp>
+        <p:nvSpPr>
+          <p:cNvPr id="3" name="TextBox 2"/>
+          <p:cNvSpPr txBox="1"/>
+          <p:nvPr/>
+        </p:nvSpPr>
+        <p:spPr>
+          <a:xfrm>
+            <a:off x="822960" y="1417320"/>
+            <a:ext cx="2743200" cy="1097280"/>
+          </a:xfrm>
+          <a:prstGeom prst="rect">
+            <a:avLst/>
+          </a:prstGeom>
+          <a:noFill/>
+        </p:spPr>
+        <p:txBody>
+          <a:bodyPr wrap="square" anchor="t">
+            <a:spAutoFit/>
+          </a:bodyPr>
+          <a:lstStyle/>
+          <a:p>
+            <a:pPr algn="l">
+              <a:lnSpc>
+                <a:spcPct val="100000"/>
+              </a:lnSpc>
+            </a:pPr>
+            <a:r>
+              <a:rPr sz="6400" b="1">
+                <a:solidFill>
+                  <a:srgbClr val="00FF41"/>
+                </a:solidFill>
+                <a:latin typeface="Courier New"/>
+              </a:rPr>
+              <a:t>05</a:t>
+            </a:r>
+          </a:p>
+        </p:txBody>
+      </p:sp>
+      <p:sp>
+        <p:nvSpPr>
+          <p:cNvPr id="4" name="TextBox 3"/>
+          <p:cNvSpPr txBox="1"/>
+          <p:nvPr/>
+        </p:nvSpPr>
+        <p:spPr>
+          <a:xfrm>
+            <a:off x="841248" y="2487168"/>
+            <a:ext cx="10424160" cy="457200"/>
+          </a:xfrm>
+          <a:prstGeom prst="rect">
+            <a:avLst/>
+          </a:prstGeom>
+          <a:noFill/>
+        </p:spPr>
+        <p:txBody>
+          <a:bodyPr wrap="square" anchor="t">
+            <a:spAutoFit/>
+          </a:bodyPr>
+          <a:lstStyle/>
+          <a:p>
+            <a:pPr algn="l">
+              <a:lnSpc>
+                <a:spcPct val="100000"/>
+              </a:lnSpc>
+            </a:pPr>
+            <a:r>
+              <a:rPr sz="1500" b="1">
+                <a:solidFill>
+                  <a:srgbClr val="00FF41"/>
+                </a:solidFill>
+                <a:latin typeface="Courier New"/>
+              </a:rPr>
+              <a:t>SO WHAT</a:t>
+            </a:r>
+          </a:p>
+        </p:txBody>
+      </p:sp>
+      <p:sp>
+        <p:nvSpPr>
+          <p:cNvPr id="5" name="TextBox 4"/>
+          <p:cNvSpPr txBox="1"/>
+          <p:nvPr/>
+        </p:nvSpPr>
+        <p:spPr>
+          <a:xfrm>
+            <a:off x="804672" y="2971800"/>
+            <a:ext cx="10607040" cy="1097280"/>
+          </a:xfrm>
+          <a:prstGeom prst="rect">
+            <a:avLst/>
+          </a:prstGeom>
+          <a:noFill/>
+        </p:spPr>
+        <p:txBody>
+          <a:bodyPr wrap="square" anchor="t">
+            <a:spAutoFit/>
+          </a:bodyPr>
+          <a:lstStyle/>
+          <a:p>
+            <a:pPr algn="l">
+              <a:lnSpc>
+                <a:spcPct val="103000"/>
+              </a:lnSpc>
+            </a:pPr>
+            <a:r>
+              <a:rPr sz="3800" b="1">
+                <a:solidFill>
+                  <a:srgbClr val="F5F7FA"/>
+                </a:solidFill>
+                <a:latin typeface="Arial"/>
+              </a:rPr>
+              <a:t>Our next design brief</a:t>
+            </a:r>
+          </a:p>
+        </p:txBody>
+      </p:sp>
+      <p:sp>
+        <p:nvSpPr>
+          <p:cNvPr id="6" name="TextBox 5"/>
+          <p:cNvSpPr txBox="1"/>
+          <p:nvPr/>
+        </p:nvSpPr>
+        <p:spPr>
+          <a:xfrm>
+            <a:off x="841248" y="4224528"/>
+            <a:ext cx="10424160" cy="1737360"/>
+          </a:xfrm>
+          <a:prstGeom prst="rect">
+            <a:avLst/>
+          </a:prstGeom>
+          <a:noFill/>
+        </p:spPr>
+        <p:txBody>
+          <a:bodyPr wrap="square" anchor="t">
+            <a:spAutoFit/>
+          </a:bodyPr>
+          <a:lstStyle/>
+          <a:p>
+            <a:pPr algn="l">
+              <a:lnSpc>
+                <a:spcPct val="128000"/>
+              </a:lnSpc>
+            </a:pPr>
+            <a:r>
+              <a:rPr sz="1700" b="1">
+                <a:solidFill>
+                  <a:srgbClr val="00FF41"/>
+                </a:solidFill>
+                <a:latin typeface="Arial"/>
+              </a:rPr>
+              <a:t>→  </a:t>
+            </a:r>
+            <a:r>
+              <a:rPr sz="1700" b="0">
+                <a:solidFill>
+                  <a:srgbClr val="8A94A6"/>
+                </a:solidFill>
+                <a:latin typeface="Arial"/>
+              </a:rPr>
+              <a:t>Verification is a beginning, not a verdict.</a:t>
+            </a:r>
+          </a:p>
+          <a:p>
+            <a:pPr algn="l">
+              <a:lnSpc>
+                <a:spcPct val="128000"/>
+              </a:lnSpc>
+            </a:pPr>
+            <a:r>
+              <a:rPr sz="1700" b="1">
+                <a:solidFill>
+                  <a:srgbClr val="00FF41"/>
+                </a:solidFill>
+                <a:latin typeface="Arial"/>
+              </a:rPr>
+              <a:t>→  </a:t>
+            </a:r>
+            <a:r>
+              <a:rPr sz="1700" b="0">
+                <a:solidFill>
+                  <a:srgbClr val="8A94A6"/>
+                </a:solidFill>
+                <a:latin typeface="Arial"/>
+              </a:rPr>
+              <a:t>What OTHER design could actually achieve this value?</a:t>
+            </a:r>
+          </a:p>
+          <a:p>
+            <a:pPr algn="l">
+              <a:lnSpc>
+                <a:spcPct val="128000"/>
+              </a:lnSpc>
+            </a:pPr>
+            <a:r>
+              <a:rPr sz="1700" b="1">
+                <a:solidFill>
+                  <a:srgbClr val="00FF41"/>
+                </a:solidFill>
+                <a:latin typeface="Arial"/>
+              </a:rPr>
+              <a:t>→  </a:t>
+            </a:r>
+            <a:r>
+              <a:rPr sz="1700" b="0">
+                <a:solidFill>
+                  <a:srgbClr val="8A94A6"/>
+                </a:solidFill>
+                <a:latin typeface="Arial"/>
+              </a:rPr>
+              <a:t>What should the next cycle discover? (You carry this into Wednesday.)</a:t>
+            </a:r>
+          </a:p>
+        </p:txBody>
+      </p:sp>
+      <p:sp>
+        <p:nvSpPr>
+          <p:cNvPr id="7" name="TextBox 6"/>
+          <p:cNvSpPr txBox="1"/>
+          <p:nvPr/>
+        </p:nvSpPr>
+        <p:spPr>
+          <a:xfrm>
+            <a:off x="640080" y="6355080"/>
+            <a:ext cx="10972800" cy="365760"/>
+          </a:xfrm>
+          <a:prstGeom prst="rect">
+            <a:avLst/>
+          </a:prstGeom>
+          <a:noFill/>
+        </p:spPr>
+        <p:txBody>
+          <a:bodyPr wrap="square" anchor="t">
+            <a:spAutoFit/>
+          </a:bodyPr>
+          <a:lstStyle/>
+          <a:p>
+            <a:pPr algn="l">
+              <a:lnSpc>
+                <a:spcPct val="100000"/>
+              </a:lnSpc>
+            </a:pPr>
+            <a:r>
+              <a:rPr sz="1000" b="0">
+                <a:solidFill>
+                  <a:srgbClr val="5A6474"/>
+                </a:solidFill>
+                <a:latin typeface="Courier New"/>
+              </a:rPr>
+              <a:t>Value Verification · TECHIE 1121 · Cornell Tech · Tue Jul 28</a:t>
+            </a:r>
+          </a:p>
+        </p:txBody>
+      </p:sp>
+    </p:spTree>
+  </p:cSld>
+  <p:clrMapOvr>
+    <a:masterClrMapping/>
+  </p:clrMapOvr>
+</p:sld>
+</file>
+
+<file path=ppt/slides/slide11.xml><?xml version="1.0" encoding="utf-8"?>
+<p:sld xmlns:a="http://schemas.openxmlformats.org/drawingml/2006/main" xmlns:p="http://schemas.openxmlformats.org/presentationml/2006/main" xmlns:r="http://schemas.openxmlformats.org/officeDocument/2006/relationships">
+  <p:cSld>
+    <p:bg>
+      <p:bgPr>
+        <a:solidFill>
+          <a:srgbClr val="0B0E14"/>
+        </a:solidFill>
+        <a:effectLst/>
+      </p:bgPr>
+    </p:bg>
+    <p:spTree>
+      <p:nvGrpSpPr>
+        <p:cNvPr id="1" name=""/>
+        <p:cNvGrpSpPr/>
+        <p:nvPr/>
+      </p:nvGrpSpPr>
+      <p:grpSpPr/>
+      <p:sp>
+        <p:nvSpPr>
+          <p:cNvPr id="2" name="TextBox 1"/>
+          <p:cNvSpPr txBox="1"/>
+          <p:nvPr/>
+        </p:nvSpPr>
+        <p:spPr>
+          <a:xfrm>
+            <a:off x="640080" y="502920"/>
+            <a:ext cx="10058400" cy="365760"/>
+          </a:xfrm>
+          <a:prstGeom prst="rect">
+            <a:avLst/>
+          </a:prstGeom>
+          <a:noFill/>
+        </p:spPr>
+        <p:txBody>
+          <a:bodyPr wrap="square" anchor="t">
+            <a:spAutoFit/>
+          </a:bodyPr>
+          <a:lstStyle/>
+          <a:p>
+            <a:pPr algn="l">
+              <a:lnSpc>
+                <a:spcPct val="100000"/>
+              </a:lnSpc>
+            </a:pPr>
+            <a:r>
+              <a:rPr sz="1300" b="1">
+                <a:solidFill>
+                  <a:srgbClr val="00FF41"/>
+                </a:solidFill>
+                <a:latin typeface="Courier New"/>
+              </a:rPr>
+              <a:t>SOURCES</a:t>
+            </a:r>
+          </a:p>
+        </p:txBody>
+      </p:sp>
+      <p:sp>
+        <p:nvSpPr>
+          <p:cNvPr id="3" name="Rectangle 2"/>
+          <p:cNvSpPr/>
+          <p:nvPr/>
+        </p:nvSpPr>
+        <p:spPr>
+          <a:xfrm>
+            <a:off x="640080" y="932688"/>
+            <a:ext cx="822960" cy="73152"/>
+          </a:xfrm>
+          <a:prstGeom prst="rect">
+            <a:avLst/>
+          </a:prstGeom>
+          <a:solidFill>
+            <a:srgbClr val="00FF41"/>
+          </a:solidFill>
+          <a:ln>
+            <a:noFill/>
+          </a:ln>
+          <a:effectLst/>
+        </p:spPr>
+        <p:style>
+          <a:lnRef idx="1">
+            <a:schemeClr val="accent1"/>
+          </a:lnRef>
+          <a:fillRef idx="3">
+            <a:schemeClr val="accent1"/>
+          </a:fillRef>
+          <a:effectRef idx="2">
+            <a:schemeClr val="accent1"/>
+          </a:effectRef>
+          <a:fontRef idx="minor">
+            <a:schemeClr val="lt1"/>
+          </a:fontRef>
+        </p:style>
+        <p:txBody>
+          <a:bodyPr rtlCol="0" anchor="ctr"/>
+          <a:lstStyle/>
+          <a:p>
+            <a:pPr algn="ctr"/>
+          </a:p>
+        </p:txBody>
+      </p:sp>
+      <p:sp>
+        <p:nvSpPr>
+          <p:cNvPr id="4" name="TextBox 3"/>
+          <p:cNvSpPr txBox="1"/>
+          <p:nvPr/>
+        </p:nvSpPr>
+        <p:spPr>
+          <a:xfrm>
+            <a:off x="640080" y="1188720"/>
+            <a:ext cx="10972800" cy="914400"/>
+          </a:xfrm>
+          <a:prstGeom prst="rect">
+            <a:avLst/>
+          </a:prstGeom>
+          <a:noFill/>
+        </p:spPr>
+        <p:txBody>
+          <a:bodyPr wrap="square" anchor="t">
+            <a:spAutoFit/>
+          </a:bodyPr>
+          <a:lstStyle/>
+          <a:p>
+            <a:pPr algn="l">
+              <a:lnSpc>
+                <a:spcPct val="100000"/>
+              </a:lnSpc>
+            </a:pPr>
+            <a:r>
+              <a:rPr sz="3200" b="1">
+                <a:solidFill>
+                  <a:srgbClr val="F5F7FA"/>
+                </a:solidFill>
+                <a:latin typeface="Arial"/>
+              </a:rPr>
+              <a:t>What we read</a:t>
+            </a:r>
+          </a:p>
+        </p:txBody>
+      </p:sp>
+      <p:sp>
+        <p:nvSpPr>
+          <p:cNvPr id="5" name="TextBox 4"/>
+          <p:cNvSpPr txBox="1"/>
+          <p:nvPr/>
+        </p:nvSpPr>
+        <p:spPr>
+          <a:xfrm>
+            <a:off x="658368" y="2377440"/>
+            <a:ext cx="10881360" cy="3108960"/>
+          </a:xfrm>
+          <a:prstGeom prst="rect">
+            <a:avLst/>
+          </a:prstGeom>
+          <a:noFill/>
+        </p:spPr>
+        <p:txBody>
+          <a:bodyPr wrap="square" anchor="t">
+            <a:spAutoFit/>
+          </a:bodyPr>
+          <a:lstStyle/>
+          <a:p>
+            <a:pPr algn="l">
+              <a:lnSpc>
+                <a:spcPct val="145000"/>
+              </a:lnSpc>
+            </a:pPr>
+            <a:r>
+              <a:rPr sz="1700" b="1">
+                <a:solidFill>
+                  <a:srgbClr val="00FF41"/>
+                </a:solidFill>
+                <a:latin typeface="Arial"/>
+              </a:rPr>
+              <a:t>•  </a:t>
+            </a:r>
+            <a:r>
+              <a:rPr sz="1700" b="0">
+                <a:solidFill>
+                  <a:srgbClr val="8A94A6"/>
+                </a:solidFill>
+                <a:latin typeface="Arial"/>
+              </a:rPr>
+              <a:t>Author, Year. Title. Where it appeared.  —  what it found</a:t>
+            </a:r>
+          </a:p>
+          <a:p>
+            <a:pPr algn="l">
+              <a:lnSpc>
+                <a:spcPct val="145000"/>
+              </a:lnSpc>
+            </a:pPr>
+            <a:r>
+              <a:rPr sz="1700" b="1">
+                <a:solidFill>
+                  <a:srgbClr val="00FF41"/>
+                </a:solidFill>
+                <a:latin typeface="Arial"/>
+              </a:rPr>
+              <a:t>•  </a:t>
+            </a:r>
+            <a:r>
+              <a:rPr sz="1700" b="0">
+                <a:solidFill>
+                  <a:srgbClr val="8A94A6"/>
+                </a:solidFill>
+                <a:latin typeface="Arial"/>
+              </a:rPr>
+              <a:t>Author, Year. Title. Where it appeared.  —  what it found</a:t>
+            </a:r>
+          </a:p>
+          <a:p>
+            <a:pPr algn="l">
+              <a:lnSpc>
+                <a:spcPct val="145000"/>
+              </a:lnSpc>
+            </a:pPr>
+            <a:r>
+              <a:rPr sz="1700" b="1">
+                <a:solidFill>
+                  <a:srgbClr val="00FF41"/>
+                </a:solidFill>
+                <a:latin typeface="Arial"/>
+              </a:rPr>
+              <a:t>•  </a:t>
+            </a:r>
+            <a:r>
+              <a:rPr sz="1700" b="0">
+                <a:solidFill>
+                  <a:srgbClr val="8A94A6"/>
+                </a:solidFill>
+                <a:latin typeface="Arial"/>
+              </a:rPr>
+              <a:t>Author, Year. Title. Where it appeared.  —  what it found</a:t>
+            </a:r>
+          </a:p>
+          <a:p>
+            <a:pPr algn="l">
+              <a:lnSpc>
+                <a:spcPct val="145000"/>
+              </a:lnSpc>
+            </a:pPr>
+            <a:r>
+              <a:rPr sz="1700" b="1">
+                <a:solidFill>
+                  <a:srgbClr val="00FF41"/>
+                </a:solidFill>
+                <a:latin typeface="Arial"/>
+              </a:rPr>
+              <a:t>•  </a:t>
+            </a:r>
+            <a:r>
+              <a:rPr sz="1700" b="0">
+                <a:solidFill>
+                  <a:srgbClr val="8A94A6"/>
+                </a:solidFill>
+                <a:latin typeface="Arial"/>
+              </a:rPr>
+              <a:t>Author, Year. Title. Where it appeared.  —  what it found</a:t>
+            </a:r>
+          </a:p>
+        </p:txBody>
+      </p:sp>
+      <p:sp>
+        <p:nvSpPr>
+          <p:cNvPr id="6" name="TextBox 5"/>
+          <p:cNvSpPr txBox="1"/>
+          <p:nvPr/>
+        </p:nvSpPr>
+        <p:spPr>
+          <a:xfrm>
+            <a:off x="658368" y="5715000"/>
+            <a:ext cx="10881360" cy="365760"/>
+          </a:xfrm>
+          <a:prstGeom prst="rect">
+            <a:avLst/>
+          </a:prstGeom>
+          <a:noFill/>
+        </p:spPr>
+        <p:txBody>
+          <a:bodyPr wrap="square" anchor="t">
+            <a:spAutoFit/>
+          </a:bodyPr>
+          <a:lstStyle/>
+          <a:p>
+            <a:pPr algn="l">
+              <a:lnSpc>
+                <a:spcPct val="100000"/>
+              </a:lnSpc>
+            </a:pPr>
+            <a:r>
+              <a:rPr sz="1300" b="0">
+                <a:solidFill>
+                  <a:srgbClr val="5A6474"/>
+                </a:solidFill>
+                <a:latin typeface="Courier New"/>
+              </a:rPr>
+              <a:t>Real papers only — never invent a citation.</a:t>
+            </a:r>
+          </a:p>
+        </p:txBody>
+      </p:sp>
+      <p:sp>
+        <p:nvSpPr>
+          <p:cNvPr id="7" name="TextBox 6"/>
+          <p:cNvSpPr txBox="1"/>
+          <p:nvPr/>
+        </p:nvSpPr>
+        <p:spPr>
+          <a:xfrm>
+            <a:off x="640080" y="6355080"/>
+            <a:ext cx="10972800" cy="365760"/>
+          </a:xfrm>
+          <a:prstGeom prst="rect">
+            <a:avLst/>
+          </a:prstGeom>
+          <a:noFill/>
+        </p:spPr>
+        <p:txBody>
+          <a:bodyPr wrap="square" anchor="t">
+            <a:spAutoFit/>
+          </a:bodyPr>
+          <a:lstStyle/>
+          <a:p>
+            <a:pPr algn="l">
+              <a:lnSpc>
+                <a:spcPct val="100000"/>
+              </a:lnSpc>
+            </a:pPr>
+            <a:r>
+              <a:rPr sz="1000" b="0">
+                <a:solidFill>
+                  <a:srgbClr val="5A6474"/>
+                </a:solidFill>
+                <a:latin typeface="Courier New"/>
+              </a:rPr>
+              <a:t>Value Verification · TECHIE 1121 · Cornell Tech · Tue Jul 28</a:t>
+            </a:r>
+          </a:p>
+        </p:txBody>
+      </p:sp>
+    </p:spTree>
+  </p:cSld>
+  <p:clrMapOvr>
+    <a:masterClrMapping/>
+  </p:clrMapOvr>
+</p:sld>
+</file>
+
 <file path=ppt/slides/slide2.xml><?xml version="1.0" encoding="utf-8"?>
 <p:sld xmlns:a="http://schemas.openxmlformats.org/drawingml/2006/main" xmlns:p="http://schemas.openxmlformats.org/presentationml/2006/main" xmlns:r="http://schemas.openxmlformats.org/officeDocument/2006/relationships">
   <p:cSld>
@@ -4337,7 +5223,7 @@
                 </a:solidFill>
                 <a:latin typeface="Arial"/>
               </a:rPr>
-              <a:t>Add your own slides AFTER each header. Don't delete the headers.</a:t>
+              <a:t>Sections 01, 02, 04, 05 are the TEAM's. Section 03 has one named slide per person — that one is graded individually.</a:t>
             </a:r>
           </a:p>
           <a:p>
@@ -4362,7 +5248,7 @@
                 </a:solidFill>
                 <a:latin typeface="Arial"/>
               </a:rPr>
-              <a:t>Evidence beats assertion: screenshots, numbers, quotes from what you actually observed.</a:t>
+              <a:t>Add your own slides AFTER each header. Don't delete the headers.</a:t>
             </a:r>
           </a:p>
           <a:p>
@@ -4387,7 +5273,57 @@
                 </a:solidFill>
                 <a:latin typeface="Arial"/>
               </a:rPr>
+              <a:t>Evidence beats assertion: screenshots, numbers, quotes from what you actually observed.</a:t>
+            </a:r>
+          </a:p>
+          <a:p>
+            <a:pPr algn="l">
+              <a:lnSpc>
+                <a:spcPct val="130000"/>
+              </a:lnSpc>
+            </a:pPr>
+            <a:r>
+              <a:rPr sz="1900" b="1">
+                <a:solidFill>
+                  <a:srgbClr val="00FF41"/>
+                </a:solidFill>
+                <a:latin typeface="Arial"/>
+              </a:rPr>
+              <a:t>•  </a:t>
+            </a:r>
+            <a:r>
+              <a:rPr sz="1900" b="0">
+                <a:solidFill>
+                  <a:srgbClr val="F5F7FA"/>
+                </a:solidFill>
+                <a:latin typeface="Arial"/>
+              </a:rPr>
               <a:t>Real citations only — if you can't find the paper, leave the claim out.</a:t>
+            </a:r>
+          </a:p>
+          <a:p>
+            <a:pPr algn="l">
+              <a:lnSpc>
+                <a:spcPct val="130000"/>
+              </a:lnSpc>
+            </a:pPr>
+            <a:r>
+              <a:rPr sz="1900" b="1">
+                <a:solidFill>
+                  <a:srgbClr val="00FF41"/>
+                </a:solidFill>
+                <a:latin typeface="Arial"/>
+              </a:rPr>
+              <a:t>•  </a:t>
+            </a:r>
+            <a:r>
+              <a:rPr sz="1900" b="0">
+                <a:solidFill>
+                  <a:srgbClr val="F5F7FA"/>
+                </a:solidFill>
+                <a:latin typeface="Arial"/>
+              </a:rPr>
+              <a:t>Your reflection is NOT a document — it goes in your own lane on the team FigJam canvas.</a:t>
             </a:r>
           </a:p>
           <a:p>
@@ -5334,7 +6270,7 @@
                 </a:solidFill>
                 <a:latin typeface="Arial"/>
               </a:rPr>
-              <a:t>What WORKS in the current prototype — with evidence.</a:t>
+              <a:t>Each team member presents their OWN slide — the named slides that follow.</a:t>
             </a:r>
           </a:p>
           <a:p>
@@ -5359,7 +6295,7 @@
                 </a:solidFill>
                 <a:latin typeface="Arial"/>
               </a:rPr>
-              <a:t>What does NOT work — with evidence. An evidenced 'it doesn't' beats a hopeful 'it does'.</a:t>
+              <a:t>What WORKS and what does NOT — with evidence. An evidenced 'it doesn't' beats a hopeful 'it does'.</a:t>
             </a:r>
           </a:p>
           <a:p>
@@ -5456,14 +6392,53 @@
       <p:grpSpPr/>
       <p:sp>
         <p:nvSpPr>
-          <p:cNvPr id="2" name="Rectangle 1"/>
+          <p:cNvPr id="2" name="TextBox 1"/>
+          <p:cNvSpPr txBox="1"/>
+          <p:nvPr/>
+        </p:nvSpPr>
+        <p:spPr>
+          <a:xfrm>
+            <a:off x="640080" y="502920"/>
+            <a:ext cx="10058400" cy="365760"/>
+          </a:xfrm>
+          <a:prstGeom prst="rect">
+            <a:avLst/>
+          </a:prstGeom>
+          <a:noFill/>
+        </p:spPr>
+        <p:txBody>
+          <a:bodyPr wrap="square" anchor="t">
+            <a:spAutoFit/>
+          </a:bodyPr>
+          <a:lstStyle/>
+          <a:p>
+            <a:pPr algn="l">
+              <a:lnSpc>
+                <a:spcPct val="100000"/>
+              </a:lnSpc>
+            </a:pPr>
+            <a:r>
+              <a:rPr sz="1300" b="1">
+                <a:solidFill>
+                  <a:srgbClr val="00FF41"/>
+                </a:solidFill>
+                <a:latin typeface="Courier New"/>
+              </a:rPr>
+              <a:t>03.1  ·  YOUR SECTION (graded individually)</a:t>
+            </a:r>
+          </a:p>
+        </p:txBody>
+      </p:sp>
+      <p:sp>
+        <p:nvSpPr>
+          <p:cNvPr id="3" name="Rectangle 2"/>
           <p:cNvSpPr/>
           <p:nvPr/>
         </p:nvSpPr>
         <p:spPr>
           <a:xfrm>
-            <a:off x="0" y="0"/>
-            <a:ext cx="256032" cy="6858000"/>
+            <a:off x="640080" y="932688"/>
+            <a:ext cx="822960" cy="73152"/>
           </a:xfrm>
           <a:prstGeom prst="rect">
             <a:avLst/>
@@ -5500,14 +6475,14 @@
       </p:sp>
       <p:sp>
         <p:nvSpPr>
-          <p:cNvPr id="3" name="TextBox 2"/>
+          <p:cNvPr id="4" name="TextBox 3"/>
           <p:cNvSpPr txBox="1"/>
           <p:nvPr/>
         </p:nvSpPr>
         <p:spPr>
           <a:xfrm>
-            <a:off x="822960" y="1417320"/>
-            <a:ext cx="2743200" cy="1097280"/>
+            <a:off x="640080" y="1170432"/>
+            <a:ext cx="10972800" cy="914400"/>
           </a:xfrm>
           <a:prstGeom prst="rect">
             <a:avLst/>
@@ -5526,27 +6501,27 @@
               </a:lnSpc>
             </a:pPr>
             <a:r>
-              <a:rPr sz="6400" b="1">
-                <a:solidFill>
-                  <a:srgbClr val="00FF41"/>
-                </a:solidFill>
-                <a:latin typeface="Courier New"/>
-              </a:rPr>
-              <a:t>04</a:t>
-            </a:r>
-          </a:p>
-        </p:txBody>
-      </p:sp>
-      <p:sp>
-        <p:nvSpPr>
-          <p:cNvPr id="4" name="TextBox 3"/>
+              <a:rPr sz="3600" b="1">
+                <a:solidFill>
+                  <a:srgbClr val="F5F7FA"/>
+                </a:solidFill>
+                <a:latin typeface="Arial"/>
+              </a:rPr>
+              <a:t>Emily Tai</a:t>
+            </a:r>
+          </a:p>
+        </p:txBody>
+      </p:sp>
+      <p:sp>
+        <p:nvSpPr>
+          <p:cNvPr id="5" name="TextBox 4"/>
           <p:cNvSpPr txBox="1"/>
           <p:nvPr/>
         </p:nvSpPr>
         <p:spPr>
           <a:xfrm>
-            <a:off x="841248" y="2487168"/>
-            <a:ext cx="10424160" cy="457200"/>
+            <a:off x="658368" y="2286000"/>
+            <a:ext cx="10881360" cy="2834640"/>
           </a:xfrm>
           <a:prstGeom prst="rect">
             <a:avLst/>
@@ -5555,6 +6530,175 @@
         </p:spPr>
         <p:txBody>
           <a:bodyPr wrap="square" anchor="t">
+            <a:spAutoFit/>
+          </a:bodyPr>
+          <a:lstStyle/>
+          <a:p>
+            <a:pPr algn="l">
+              <a:lnSpc>
+                <a:spcPct val="134000"/>
+              </a:lnSpc>
+            </a:pPr>
+            <a:r>
+              <a:rPr sz="1900" b="1">
+                <a:solidFill>
+                  <a:srgbClr val="00FF41"/>
+                </a:solidFill>
+                <a:latin typeface="Arial"/>
+              </a:rPr>
+              <a:t>→  </a:t>
+            </a:r>
+            <a:r>
+              <a:rPr sz="1900" b="0">
+                <a:solidFill>
+                  <a:srgbClr val="F5F7FA"/>
+                </a:solidFill>
+                <a:latin typeface="Arial"/>
+              </a:rPr>
+              <a:t>The lens + method I ran, and why our reading demanded it</a:t>
+            </a:r>
+          </a:p>
+          <a:p>
+            <a:pPr algn="l">
+              <a:lnSpc>
+                <a:spcPct val="134000"/>
+              </a:lnSpc>
+            </a:pPr>
+            <a:r>
+              <a:rPr sz="1900" b="1">
+                <a:solidFill>
+                  <a:srgbClr val="00FF41"/>
+                </a:solidFill>
+                <a:latin typeface="Arial"/>
+              </a:rPr>
+              <a:t>→  </a:t>
+            </a:r>
+            <a:r>
+              <a:rPr sz="1900" b="0">
+                <a:solidFill>
+                  <a:srgbClr val="F5F7FA"/>
+                </a:solidFill>
+                <a:latin typeface="Arial"/>
+              </a:rPr>
+              <a:t>My evidence - what I actually observed or measured</a:t>
+            </a:r>
+          </a:p>
+          <a:p>
+            <a:pPr algn="l">
+              <a:lnSpc>
+                <a:spcPct val="134000"/>
+              </a:lnSpc>
+            </a:pPr>
+            <a:r>
+              <a:rPr sz="1900" b="1">
+                <a:solidFill>
+                  <a:srgbClr val="00FF41"/>
+                </a:solidFill>
+                <a:latin typeface="Arial"/>
+              </a:rPr>
+              <a:t>→  </a:t>
+            </a:r>
+            <a:r>
+              <a:rPr sz="1900" b="0">
+                <a:solidFill>
+                  <a:srgbClr val="F5F7FA"/>
+                </a:solidFill>
+                <a:latin typeface="Arial"/>
+              </a:rPr>
+              <a:t>What this says WORKS - and what does NOT</a:t>
+            </a:r>
+          </a:p>
+          <a:p>
+            <a:pPr algn="l">
+              <a:lnSpc>
+                <a:spcPct val="134000"/>
+              </a:lnSpc>
+            </a:pPr>
+            <a:r>
+              <a:rPr sz="1900" b="1">
+                <a:solidFill>
+                  <a:srgbClr val="00FF41"/>
+                </a:solidFill>
+                <a:latin typeface="Arial"/>
+              </a:rPr>
+              <a:t>→  </a:t>
+            </a:r>
+            <a:r>
+              <a:rPr sz="1900" b="0">
+                <a:solidFill>
+                  <a:srgbClr val="F5F7FA"/>
+                </a:solidFill>
+                <a:latin typeface="Arial"/>
+              </a:rPr>
+              <a:t>The paper I found (real citation) and what it changes</a:t>
+            </a:r>
+          </a:p>
+        </p:txBody>
+      </p:sp>
+      <p:sp>
+        <p:nvSpPr>
+          <p:cNvPr id="6" name="Rounded Rectangle 5"/>
+          <p:cNvSpPr/>
+          <p:nvPr/>
+        </p:nvSpPr>
+        <p:spPr>
+          <a:xfrm>
+            <a:off x="640080" y="5440680"/>
+            <a:ext cx="10881360" cy="658368"/>
+          </a:xfrm>
+          <a:prstGeom prst="roundRect">
+            <a:avLst/>
+          </a:prstGeom>
+          <a:solidFill>
+            <a:srgbClr val="151B26"/>
+          </a:solidFill>
+          <a:ln w="19050">
+            <a:solidFill>
+              <a:srgbClr val="00FF41"/>
+            </a:solidFill>
+          </a:ln>
+          <a:effectLst/>
+        </p:spPr>
+        <p:style>
+          <a:lnRef idx="1">
+            <a:schemeClr val="accent1"/>
+          </a:lnRef>
+          <a:fillRef idx="3">
+            <a:schemeClr val="accent1"/>
+          </a:fillRef>
+          <a:effectRef idx="2">
+            <a:schemeClr val="accent1"/>
+          </a:effectRef>
+          <a:fontRef idx="minor">
+            <a:schemeClr val="lt1"/>
+          </a:fontRef>
+        </p:style>
+        <p:txBody>
+          <a:bodyPr rtlCol="0" anchor="ctr"/>
+          <a:lstStyle/>
+          <a:p>
+            <a:pPr algn="ctr"/>
+          </a:p>
+        </p:txBody>
+      </p:sp>
+      <p:sp>
+        <p:nvSpPr>
+          <p:cNvPr id="7" name="TextBox 6"/>
+          <p:cNvSpPr txBox="1"/>
+          <p:nvPr/>
+        </p:nvSpPr>
+        <p:spPr>
+          <a:xfrm>
+            <a:off x="914400" y="5440680"/>
+            <a:ext cx="10332720" cy="658368"/>
+          </a:xfrm>
+          <a:prstGeom prst="rect">
+            <a:avLst/>
+          </a:prstGeom>
+          <a:noFill/>
+        </p:spPr>
+        <p:txBody>
+          <a:bodyPr wrap="square" anchor="ctr">
             <a:spAutoFit/>
           </a:bodyPr>
           <a:lstStyle/>
@@ -5565,157 +6709,29 @@
               </a:lnSpc>
             </a:pPr>
             <a:r>
+              <a:rPr sz="1600" b="1">
+                <a:solidFill>
+                  <a:srgbClr val="00FF41"/>
+                </a:solidFill>
+                <a:latin typeface="Arial"/>
+              </a:rPr>
+              <a:t>▸  </a:t>
+            </a:r>
+            <a:r>
               <a:rPr sz="1500" b="1">
                 <a:solidFill>
-                  <a:srgbClr val="00FF41"/>
-                </a:solidFill>
-                <a:latin typeface="Courier New"/>
-              </a:rPr>
-              <a:t>PART 3 — OUTLOOK</a:t>
-            </a:r>
-          </a:p>
-        </p:txBody>
-      </p:sp>
-      <p:sp>
-        <p:nvSpPr>
-          <p:cNvPr id="5" name="TextBox 4"/>
-          <p:cNvSpPr txBox="1"/>
-          <p:nvPr/>
-        </p:nvSpPr>
-        <p:spPr>
-          <a:xfrm>
-            <a:off x="804672" y="2971800"/>
-            <a:ext cx="10607040" cy="1097280"/>
-          </a:xfrm>
-          <a:prstGeom prst="rect">
-            <a:avLst/>
-          </a:prstGeom>
-          <a:noFill/>
-        </p:spPr>
-        <p:txBody>
-          <a:bodyPr wrap="square" anchor="t">
-            <a:spAutoFit/>
-          </a:bodyPr>
-          <a:lstStyle/>
-          <a:p>
-            <a:pPr algn="l">
-              <a:lnSpc>
-                <a:spcPct val="103000"/>
-              </a:lnSpc>
-            </a:pPr>
-            <a:r>
-              <a:rPr sz="3800" b="1">
-                <a:solidFill>
                   <a:srgbClr val="F5F7FA"/>
                 </a:solidFill>
                 <a:latin typeface="Arial"/>
               </a:rPr>
-              <a:t>What related research has already found</a:t>
-            </a:r>
-          </a:p>
-        </p:txBody>
-      </p:sp>
-      <p:sp>
-        <p:nvSpPr>
-          <p:cNvPr id="6" name="TextBox 5"/>
-          <p:cNvSpPr txBox="1"/>
-          <p:nvPr/>
-        </p:nvSpPr>
-        <p:spPr>
-          <a:xfrm>
-            <a:off x="841248" y="4224528"/>
-            <a:ext cx="10424160" cy="1737360"/>
-          </a:xfrm>
-          <a:prstGeom prst="rect">
-            <a:avLst/>
-          </a:prstGeom>
-          <a:noFill/>
-        </p:spPr>
-        <p:txBody>
-          <a:bodyPr wrap="square" anchor="t">
-            <a:spAutoFit/>
-          </a:bodyPr>
-          <a:lstStyle/>
-          <a:p>
-            <a:pPr algn="l">
-              <a:lnSpc>
-                <a:spcPct val="128000"/>
-              </a:lnSpc>
-            </a:pPr>
-            <a:r>
-              <a:rPr sz="1700" b="1">
-                <a:solidFill>
-                  <a:srgbClr val="00FF41"/>
-                </a:solidFill>
-                <a:latin typeface="Arial"/>
-              </a:rPr>
-              <a:t>→  </a:t>
-            </a:r>
-            <a:r>
-              <a:rPr sz="1700" b="0">
-                <a:solidFill>
-                  <a:srgbClr val="8A94A6"/>
-                </a:solidFill>
-                <a:latin typeface="Arial"/>
-              </a:rPr>
-              <a:t>What have others tried in order to move this value?</a:t>
-            </a:r>
-          </a:p>
-          <a:p>
-            <a:pPr algn="l">
-              <a:lnSpc>
-                <a:spcPct val="128000"/>
-              </a:lnSpc>
-            </a:pPr>
-            <a:r>
-              <a:rPr sz="1700" b="1">
-                <a:solidFill>
-                  <a:srgbClr val="00FF41"/>
-                </a:solidFill>
-                <a:latin typeface="Arial"/>
-              </a:rPr>
-              <a:t>→  </a:t>
-            </a:r>
-            <a:r>
-              <a:rPr sz="1700" b="0">
-                <a:solidFill>
-                  <a:srgbClr val="8A94A6"/>
-                </a:solidFill>
-                <a:latin typeface="Arial"/>
-              </a:rPr>
-              <a:t>What worked — and what failed?</a:t>
-            </a:r>
-          </a:p>
-          <a:p>
-            <a:pPr algn="l">
-              <a:lnSpc>
-                <a:spcPct val="128000"/>
-              </a:lnSpc>
-            </a:pPr>
-            <a:r>
-              <a:rPr sz="1700" b="1">
-                <a:solidFill>
-                  <a:srgbClr val="00FF41"/>
-                </a:solidFill>
-                <a:latin typeface="Arial"/>
-              </a:rPr>
-              <a:t>→  </a:t>
-            </a:r>
-            <a:r>
-              <a:rPr sz="1700" b="0">
-                <a:solidFill>
-                  <a:srgbClr val="8A94A6"/>
-                </a:solidFill>
-                <a:latin typeface="Arial"/>
-              </a:rPr>
-              <a:t>2–3 REAL sources. Never invent a citation.</a:t>
-            </a:r>
-          </a:p>
-        </p:txBody>
-      </p:sp>
-      <p:sp>
-        <p:nvSpPr>
-          <p:cNvPr id="7" name="TextBox 6"/>
+              <a:t>This slide is yours. Add more slides behind it if you need them - keep your name on them.</a:t>
+            </a:r>
+          </a:p>
+        </p:txBody>
+      </p:sp>
+      <p:sp>
+        <p:nvSpPr>
+          <p:cNvPr id="8" name="TextBox 7"/>
           <p:cNvSpPr txBox="1"/>
           <p:nvPr/>
         </p:nvSpPr>
@@ -5780,14 +6796,53 @@
       <p:grpSpPr/>
       <p:sp>
         <p:nvSpPr>
-          <p:cNvPr id="2" name="Rectangle 1"/>
+          <p:cNvPr id="2" name="TextBox 1"/>
+          <p:cNvSpPr txBox="1"/>
+          <p:nvPr/>
+        </p:nvSpPr>
+        <p:spPr>
+          <a:xfrm>
+            <a:off x="640080" y="502920"/>
+            <a:ext cx="10058400" cy="365760"/>
+          </a:xfrm>
+          <a:prstGeom prst="rect">
+            <a:avLst/>
+          </a:prstGeom>
+          <a:noFill/>
+        </p:spPr>
+        <p:txBody>
+          <a:bodyPr wrap="square" anchor="t">
+            <a:spAutoFit/>
+          </a:bodyPr>
+          <a:lstStyle/>
+          <a:p>
+            <a:pPr algn="l">
+              <a:lnSpc>
+                <a:spcPct val="100000"/>
+              </a:lnSpc>
+            </a:pPr>
+            <a:r>
+              <a:rPr sz="1300" b="1">
+                <a:solidFill>
+                  <a:srgbClr val="00FF41"/>
+                </a:solidFill>
+                <a:latin typeface="Courier New"/>
+              </a:rPr>
+              <a:t>03.2  ·  YOUR SECTION (graded individually)</a:t>
+            </a:r>
+          </a:p>
+        </p:txBody>
+      </p:sp>
+      <p:sp>
+        <p:nvSpPr>
+          <p:cNvPr id="3" name="Rectangle 2"/>
           <p:cNvSpPr/>
           <p:nvPr/>
         </p:nvSpPr>
         <p:spPr>
           <a:xfrm>
-            <a:off x="0" y="0"/>
-            <a:ext cx="256032" cy="6858000"/>
+            <a:off x="640080" y="932688"/>
+            <a:ext cx="822960" cy="73152"/>
           </a:xfrm>
           <a:prstGeom prst="rect">
             <a:avLst/>
@@ -5824,14 +6879,14 @@
       </p:sp>
       <p:sp>
         <p:nvSpPr>
-          <p:cNvPr id="3" name="TextBox 2"/>
+          <p:cNvPr id="4" name="TextBox 3"/>
           <p:cNvSpPr txBox="1"/>
           <p:nvPr/>
         </p:nvSpPr>
         <p:spPr>
           <a:xfrm>
-            <a:off x="822960" y="1417320"/>
-            <a:ext cx="2743200" cy="1097280"/>
+            <a:off x="640080" y="1170432"/>
+            <a:ext cx="10972800" cy="914400"/>
           </a:xfrm>
           <a:prstGeom prst="rect">
             <a:avLst/>
@@ -5850,27 +6905,27 @@
               </a:lnSpc>
             </a:pPr>
             <a:r>
-              <a:rPr sz="6400" b="1">
-                <a:solidFill>
-                  <a:srgbClr val="00FF41"/>
-                </a:solidFill>
-                <a:latin typeface="Courier New"/>
-              </a:rPr>
-              <a:t>05</a:t>
-            </a:r>
-          </a:p>
-        </p:txBody>
-      </p:sp>
-      <p:sp>
-        <p:nvSpPr>
-          <p:cNvPr id="4" name="TextBox 3"/>
+              <a:rPr sz="3600" b="1">
+                <a:solidFill>
+                  <a:srgbClr val="F5F7FA"/>
+                </a:solidFill>
+                <a:latin typeface="Arial"/>
+              </a:rPr>
+              <a:t>Kylie Cheung</a:t>
+            </a:r>
+          </a:p>
+        </p:txBody>
+      </p:sp>
+      <p:sp>
+        <p:nvSpPr>
+          <p:cNvPr id="5" name="TextBox 4"/>
           <p:cNvSpPr txBox="1"/>
           <p:nvPr/>
         </p:nvSpPr>
         <p:spPr>
           <a:xfrm>
-            <a:off x="841248" y="2487168"/>
-            <a:ext cx="10424160" cy="457200"/>
+            <a:off x="658368" y="2286000"/>
+            <a:ext cx="10881360" cy="2834640"/>
           </a:xfrm>
           <a:prstGeom prst="rect">
             <a:avLst/>
@@ -5879,6 +6934,175 @@
         </p:spPr>
         <p:txBody>
           <a:bodyPr wrap="square" anchor="t">
+            <a:spAutoFit/>
+          </a:bodyPr>
+          <a:lstStyle/>
+          <a:p>
+            <a:pPr algn="l">
+              <a:lnSpc>
+                <a:spcPct val="134000"/>
+              </a:lnSpc>
+            </a:pPr>
+            <a:r>
+              <a:rPr sz="1900" b="1">
+                <a:solidFill>
+                  <a:srgbClr val="00FF41"/>
+                </a:solidFill>
+                <a:latin typeface="Arial"/>
+              </a:rPr>
+              <a:t>→  </a:t>
+            </a:r>
+            <a:r>
+              <a:rPr sz="1900" b="0">
+                <a:solidFill>
+                  <a:srgbClr val="F5F7FA"/>
+                </a:solidFill>
+                <a:latin typeface="Arial"/>
+              </a:rPr>
+              <a:t>The lens + method I ran, and why our reading demanded it</a:t>
+            </a:r>
+          </a:p>
+          <a:p>
+            <a:pPr algn="l">
+              <a:lnSpc>
+                <a:spcPct val="134000"/>
+              </a:lnSpc>
+            </a:pPr>
+            <a:r>
+              <a:rPr sz="1900" b="1">
+                <a:solidFill>
+                  <a:srgbClr val="00FF41"/>
+                </a:solidFill>
+                <a:latin typeface="Arial"/>
+              </a:rPr>
+              <a:t>→  </a:t>
+            </a:r>
+            <a:r>
+              <a:rPr sz="1900" b="0">
+                <a:solidFill>
+                  <a:srgbClr val="F5F7FA"/>
+                </a:solidFill>
+                <a:latin typeface="Arial"/>
+              </a:rPr>
+              <a:t>My evidence - what I actually observed or measured</a:t>
+            </a:r>
+          </a:p>
+          <a:p>
+            <a:pPr algn="l">
+              <a:lnSpc>
+                <a:spcPct val="134000"/>
+              </a:lnSpc>
+            </a:pPr>
+            <a:r>
+              <a:rPr sz="1900" b="1">
+                <a:solidFill>
+                  <a:srgbClr val="00FF41"/>
+                </a:solidFill>
+                <a:latin typeface="Arial"/>
+              </a:rPr>
+              <a:t>→  </a:t>
+            </a:r>
+            <a:r>
+              <a:rPr sz="1900" b="0">
+                <a:solidFill>
+                  <a:srgbClr val="F5F7FA"/>
+                </a:solidFill>
+                <a:latin typeface="Arial"/>
+              </a:rPr>
+              <a:t>What this says WORKS - and what does NOT</a:t>
+            </a:r>
+          </a:p>
+          <a:p>
+            <a:pPr algn="l">
+              <a:lnSpc>
+                <a:spcPct val="134000"/>
+              </a:lnSpc>
+            </a:pPr>
+            <a:r>
+              <a:rPr sz="1900" b="1">
+                <a:solidFill>
+                  <a:srgbClr val="00FF41"/>
+                </a:solidFill>
+                <a:latin typeface="Arial"/>
+              </a:rPr>
+              <a:t>→  </a:t>
+            </a:r>
+            <a:r>
+              <a:rPr sz="1900" b="0">
+                <a:solidFill>
+                  <a:srgbClr val="F5F7FA"/>
+                </a:solidFill>
+                <a:latin typeface="Arial"/>
+              </a:rPr>
+              <a:t>The paper I found (real citation) and what it changes</a:t>
+            </a:r>
+          </a:p>
+        </p:txBody>
+      </p:sp>
+      <p:sp>
+        <p:nvSpPr>
+          <p:cNvPr id="6" name="Rounded Rectangle 5"/>
+          <p:cNvSpPr/>
+          <p:nvPr/>
+        </p:nvSpPr>
+        <p:spPr>
+          <a:xfrm>
+            <a:off x="640080" y="5440680"/>
+            <a:ext cx="10881360" cy="658368"/>
+          </a:xfrm>
+          <a:prstGeom prst="roundRect">
+            <a:avLst/>
+          </a:prstGeom>
+          <a:solidFill>
+            <a:srgbClr val="151B26"/>
+          </a:solidFill>
+          <a:ln w="19050">
+            <a:solidFill>
+              <a:srgbClr val="00FF41"/>
+            </a:solidFill>
+          </a:ln>
+          <a:effectLst/>
+        </p:spPr>
+        <p:style>
+          <a:lnRef idx="1">
+            <a:schemeClr val="accent1"/>
+          </a:lnRef>
+          <a:fillRef idx="3">
+            <a:schemeClr val="accent1"/>
+          </a:fillRef>
+          <a:effectRef idx="2">
+            <a:schemeClr val="accent1"/>
+          </a:effectRef>
+          <a:fontRef idx="minor">
+            <a:schemeClr val="lt1"/>
+          </a:fontRef>
+        </p:style>
+        <p:txBody>
+          <a:bodyPr rtlCol="0" anchor="ctr"/>
+          <a:lstStyle/>
+          <a:p>
+            <a:pPr algn="ctr"/>
+          </a:p>
+        </p:txBody>
+      </p:sp>
+      <p:sp>
+        <p:nvSpPr>
+          <p:cNvPr id="7" name="TextBox 6"/>
+          <p:cNvSpPr txBox="1"/>
+          <p:nvPr/>
+        </p:nvSpPr>
+        <p:spPr>
+          <a:xfrm>
+            <a:off x="914400" y="5440680"/>
+            <a:ext cx="10332720" cy="658368"/>
+          </a:xfrm>
+          <a:prstGeom prst="rect">
+            <a:avLst/>
+          </a:prstGeom>
+          <a:noFill/>
+        </p:spPr>
+        <p:txBody>
+          <a:bodyPr wrap="square" anchor="ctr">
             <a:spAutoFit/>
           </a:bodyPr>
           <a:lstStyle/>
@@ -5889,157 +7113,29 @@
               </a:lnSpc>
             </a:pPr>
             <a:r>
+              <a:rPr sz="1600" b="1">
+                <a:solidFill>
+                  <a:srgbClr val="00FF41"/>
+                </a:solidFill>
+                <a:latin typeface="Arial"/>
+              </a:rPr>
+              <a:t>▸  </a:t>
+            </a:r>
+            <a:r>
               <a:rPr sz="1500" b="1">
                 <a:solidFill>
-                  <a:srgbClr val="00FF41"/>
-                </a:solidFill>
-                <a:latin typeface="Courier New"/>
-              </a:rPr>
-              <a:t>SO WHAT</a:t>
-            </a:r>
-          </a:p>
-        </p:txBody>
-      </p:sp>
-      <p:sp>
-        <p:nvSpPr>
-          <p:cNvPr id="5" name="TextBox 4"/>
-          <p:cNvSpPr txBox="1"/>
-          <p:nvPr/>
-        </p:nvSpPr>
-        <p:spPr>
-          <a:xfrm>
-            <a:off x="804672" y="2971800"/>
-            <a:ext cx="10607040" cy="1097280"/>
-          </a:xfrm>
-          <a:prstGeom prst="rect">
-            <a:avLst/>
-          </a:prstGeom>
-          <a:noFill/>
-        </p:spPr>
-        <p:txBody>
-          <a:bodyPr wrap="square" anchor="t">
-            <a:spAutoFit/>
-          </a:bodyPr>
-          <a:lstStyle/>
-          <a:p>
-            <a:pPr algn="l">
-              <a:lnSpc>
-                <a:spcPct val="103000"/>
-              </a:lnSpc>
-            </a:pPr>
-            <a:r>
-              <a:rPr sz="3800" b="1">
-                <a:solidFill>
                   <a:srgbClr val="F5F7FA"/>
                 </a:solidFill>
                 <a:latin typeface="Arial"/>
               </a:rPr>
-              <a:t>Our next design brief</a:t>
-            </a:r>
-          </a:p>
-        </p:txBody>
-      </p:sp>
-      <p:sp>
-        <p:nvSpPr>
-          <p:cNvPr id="6" name="TextBox 5"/>
-          <p:cNvSpPr txBox="1"/>
-          <p:nvPr/>
-        </p:nvSpPr>
-        <p:spPr>
-          <a:xfrm>
-            <a:off x="841248" y="4224528"/>
-            <a:ext cx="10424160" cy="1737360"/>
-          </a:xfrm>
-          <a:prstGeom prst="rect">
-            <a:avLst/>
-          </a:prstGeom>
-          <a:noFill/>
-        </p:spPr>
-        <p:txBody>
-          <a:bodyPr wrap="square" anchor="t">
-            <a:spAutoFit/>
-          </a:bodyPr>
-          <a:lstStyle/>
-          <a:p>
-            <a:pPr algn="l">
-              <a:lnSpc>
-                <a:spcPct val="128000"/>
-              </a:lnSpc>
-            </a:pPr>
-            <a:r>
-              <a:rPr sz="1700" b="1">
-                <a:solidFill>
-                  <a:srgbClr val="00FF41"/>
-                </a:solidFill>
-                <a:latin typeface="Arial"/>
-              </a:rPr>
-              <a:t>→  </a:t>
-            </a:r>
-            <a:r>
-              <a:rPr sz="1700" b="0">
-                <a:solidFill>
-                  <a:srgbClr val="8A94A6"/>
-                </a:solidFill>
-                <a:latin typeface="Arial"/>
-              </a:rPr>
-              <a:t>Verification is a beginning, not a verdict.</a:t>
-            </a:r>
-          </a:p>
-          <a:p>
-            <a:pPr algn="l">
-              <a:lnSpc>
-                <a:spcPct val="128000"/>
-              </a:lnSpc>
-            </a:pPr>
-            <a:r>
-              <a:rPr sz="1700" b="1">
-                <a:solidFill>
-                  <a:srgbClr val="00FF41"/>
-                </a:solidFill>
-                <a:latin typeface="Arial"/>
-              </a:rPr>
-              <a:t>→  </a:t>
-            </a:r>
-            <a:r>
-              <a:rPr sz="1700" b="0">
-                <a:solidFill>
-                  <a:srgbClr val="8A94A6"/>
-                </a:solidFill>
-                <a:latin typeface="Arial"/>
-              </a:rPr>
-              <a:t>What OTHER design could actually achieve this value?</a:t>
-            </a:r>
-          </a:p>
-          <a:p>
-            <a:pPr algn="l">
-              <a:lnSpc>
-                <a:spcPct val="128000"/>
-              </a:lnSpc>
-            </a:pPr>
-            <a:r>
-              <a:rPr sz="1700" b="1">
-                <a:solidFill>
-                  <a:srgbClr val="00FF41"/>
-                </a:solidFill>
-                <a:latin typeface="Arial"/>
-              </a:rPr>
-              <a:t>→  </a:t>
-            </a:r>
-            <a:r>
-              <a:rPr sz="1700" b="0">
-                <a:solidFill>
-                  <a:srgbClr val="8A94A6"/>
-                </a:solidFill>
-                <a:latin typeface="Arial"/>
-              </a:rPr>
-              <a:t>What should the next cycle discover? (You carry this into Wednesday.)</a:t>
-            </a:r>
-          </a:p>
-        </p:txBody>
-      </p:sp>
-      <p:sp>
-        <p:nvSpPr>
-          <p:cNvPr id="7" name="TextBox 6"/>
+              <a:t>This slide is yours. Add more slides behind it if you need them - keep your name on them.</a:t>
+            </a:r>
+          </a:p>
+        </p:txBody>
+      </p:sp>
+      <p:sp>
+        <p:nvSpPr>
+          <p:cNvPr id="8" name="TextBox 7"/>
           <p:cNvSpPr txBox="1"/>
           <p:nvPr/>
         </p:nvSpPr>
@@ -6136,7 +7232,7 @@
                 </a:solidFill>
                 <a:latin typeface="Courier New"/>
               </a:rPr>
-              <a:t>SOURCES</a:t>
+              <a:t>03.3  ·  YOUR SECTION (graded individually)</a:t>
             </a:r>
           </a:p>
         </p:txBody>
@@ -6193,7 +7289,7 @@
         </p:nvSpPr>
         <p:spPr>
           <a:xfrm>
-            <a:off x="640080" y="1188720"/>
+            <a:off x="640080" y="1170432"/>
             <a:ext cx="10972800" cy="914400"/>
           </a:xfrm>
           <a:prstGeom prst="rect">
@@ -6213,13 +7309,13 @@
               </a:lnSpc>
             </a:pPr>
             <a:r>
-              <a:rPr sz="3200" b="1">
+              <a:rPr sz="3600" b="1">
                 <a:solidFill>
                   <a:srgbClr val="F5F7FA"/>
                 </a:solidFill>
                 <a:latin typeface="Arial"/>
               </a:rPr>
-              <a:t>What we read</a:t>
+              <a:t>Aria Sharma</a:t>
             </a:r>
           </a:p>
         </p:txBody>
@@ -6232,8 +7328,8 @@
         </p:nvSpPr>
         <p:spPr>
           <a:xfrm>
-            <a:off x="658368" y="2377440"/>
-            <a:ext cx="10881360" cy="3108960"/>
+            <a:off x="658368" y="2286000"/>
+            <a:ext cx="10881360" cy="2834640"/>
           </a:xfrm>
           <a:prstGeom prst="rect">
             <a:avLst/>
@@ -6248,115 +7344,161 @@
           <a:p>
             <a:pPr algn="l">
               <a:lnSpc>
-                <a:spcPct val="145000"/>
+                <a:spcPct val="134000"/>
               </a:lnSpc>
             </a:pPr>
             <a:r>
-              <a:rPr sz="1700" b="1">
+              <a:rPr sz="1900" b="1">
                 <a:solidFill>
                   <a:srgbClr val="00FF41"/>
                 </a:solidFill>
                 <a:latin typeface="Arial"/>
               </a:rPr>
-              <a:t>•  </a:t>
-            </a:r>
-            <a:r>
-              <a:rPr sz="1700" b="0">
-                <a:solidFill>
-                  <a:srgbClr val="8A94A6"/>
-                </a:solidFill>
-                <a:latin typeface="Arial"/>
-              </a:rPr>
-              <a:t>Author, Year. Title. Where it appeared.  —  what it found</a:t>
+              <a:t>→  </a:t>
+            </a:r>
+            <a:r>
+              <a:rPr sz="1900" b="0">
+                <a:solidFill>
+                  <a:srgbClr val="F5F7FA"/>
+                </a:solidFill>
+                <a:latin typeface="Arial"/>
+              </a:rPr>
+              <a:t>The lens + method I ran, and why our reading demanded it</a:t>
             </a:r>
           </a:p>
           <a:p>
             <a:pPr algn="l">
               <a:lnSpc>
-                <a:spcPct val="145000"/>
+                <a:spcPct val="134000"/>
               </a:lnSpc>
             </a:pPr>
             <a:r>
-              <a:rPr sz="1700" b="1">
+              <a:rPr sz="1900" b="1">
                 <a:solidFill>
                   <a:srgbClr val="00FF41"/>
                 </a:solidFill>
                 <a:latin typeface="Arial"/>
               </a:rPr>
-              <a:t>•  </a:t>
-            </a:r>
-            <a:r>
-              <a:rPr sz="1700" b="0">
-                <a:solidFill>
-                  <a:srgbClr val="8A94A6"/>
-                </a:solidFill>
-                <a:latin typeface="Arial"/>
-              </a:rPr>
-              <a:t>Author, Year. Title. Where it appeared.  —  what it found</a:t>
+              <a:t>→  </a:t>
+            </a:r>
+            <a:r>
+              <a:rPr sz="1900" b="0">
+                <a:solidFill>
+                  <a:srgbClr val="F5F7FA"/>
+                </a:solidFill>
+                <a:latin typeface="Arial"/>
+              </a:rPr>
+              <a:t>My evidence - what I actually observed or measured</a:t>
             </a:r>
           </a:p>
           <a:p>
             <a:pPr algn="l">
               <a:lnSpc>
-                <a:spcPct val="145000"/>
+                <a:spcPct val="134000"/>
               </a:lnSpc>
             </a:pPr>
             <a:r>
-              <a:rPr sz="1700" b="1">
+              <a:rPr sz="1900" b="1">
                 <a:solidFill>
                   <a:srgbClr val="00FF41"/>
                 </a:solidFill>
                 <a:latin typeface="Arial"/>
               </a:rPr>
-              <a:t>•  </a:t>
-            </a:r>
-            <a:r>
-              <a:rPr sz="1700" b="0">
-                <a:solidFill>
-                  <a:srgbClr val="8A94A6"/>
-                </a:solidFill>
-                <a:latin typeface="Arial"/>
-              </a:rPr>
-              <a:t>Author, Year. Title. Where it appeared.  —  what it found</a:t>
+              <a:t>→  </a:t>
+            </a:r>
+            <a:r>
+              <a:rPr sz="1900" b="0">
+                <a:solidFill>
+                  <a:srgbClr val="F5F7FA"/>
+                </a:solidFill>
+                <a:latin typeface="Arial"/>
+              </a:rPr>
+              <a:t>What this says WORKS - and what does NOT</a:t>
             </a:r>
           </a:p>
           <a:p>
             <a:pPr algn="l">
               <a:lnSpc>
-                <a:spcPct val="145000"/>
+                <a:spcPct val="134000"/>
               </a:lnSpc>
             </a:pPr>
             <a:r>
-              <a:rPr sz="1700" b="1">
+              <a:rPr sz="1900" b="1">
                 <a:solidFill>
                   <a:srgbClr val="00FF41"/>
                 </a:solidFill>
                 <a:latin typeface="Arial"/>
               </a:rPr>
-              <a:t>•  </a:t>
-            </a:r>
-            <a:r>
-              <a:rPr sz="1700" b="0">
-                <a:solidFill>
-                  <a:srgbClr val="8A94A6"/>
-                </a:solidFill>
-                <a:latin typeface="Arial"/>
-              </a:rPr>
-              <a:t>Author, Year. Title. Where it appeared.  —  what it found</a:t>
-            </a:r>
-          </a:p>
-        </p:txBody>
-      </p:sp>
-      <p:sp>
-        <p:nvSpPr>
-          <p:cNvPr id="6" name="TextBox 5"/>
+              <a:t>→  </a:t>
+            </a:r>
+            <a:r>
+              <a:rPr sz="1900" b="0">
+                <a:solidFill>
+                  <a:srgbClr val="F5F7FA"/>
+                </a:solidFill>
+                <a:latin typeface="Arial"/>
+              </a:rPr>
+              <a:t>The paper I found (real citation) and what it changes</a:t>
+            </a:r>
+          </a:p>
+        </p:txBody>
+      </p:sp>
+      <p:sp>
+        <p:nvSpPr>
+          <p:cNvPr id="6" name="Rounded Rectangle 5"/>
+          <p:cNvSpPr/>
+          <p:nvPr/>
+        </p:nvSpPr>
+        <p:spPr>
+          <a:xfrm>
+            <a:off x="640080" y="5440680"/>
+            <a:ext cx="10881360" cy="658368"/>
+          </a:xfrm>
+          <a:prstGeom prst="roundRect">
+            <a:avLst/>
+          </a:prstGeom>
+          <a:solidFill>
+            <a:srgbClr val="151B26"/>
+          </a:solidFill>
+          <a:ln w="19050">
+            <a:solidFill>
+              <a:srgbClr val="00FF41"/>
+            </a:solidFill>
+          </a:ln>
+          <a:effectLst/>
+        </p:spPr>
+        <p:style>
+          <a:lnRef idx="1">
+            <a:schemeClr val="accent1"/>
+          </a:lnRef>
+          <a:fillRef idx="3">
+            <a:schemeClr val="accent1"/>
+          </a:fillRef>
+          <a:effectRef idx="2">
+            <a:schemeClr val="accent1"/>
+          </a:effectRef>
+          <a:fontRef idx="minor">
+            <a:schemeClr val="lt1"/>
+          </a:fontRef>
+        </p:style>
+        <p:txBody>
+          <a:bodyPr rtlCol="0" anchor="ctr"/>
+          <a:lstStyle/>
+          <a:p>
+            <a:pPr algn="ctr"/>
+          </a:p>
+        </p:txBody>
+      </p:sp>
+      <p:sp>
+        <p:nvSpPr>
+          <p:cNvPr id="7" name="TextBox 6"/>
           <p:cNvSpPr txBox="1"/>
           <p:nvPr/>
         </p:nvSpPr>
         <p:spPr>
           <a:xfrm>
-            <a:off x="658368" y="5715000"/>
-            <a:ext cx="10881360" cy="365760"/>
+            <a:off x="914400" y="5440680"/>
+            <a:ext cx="10332720" cy="658368"/>
           </a:xfrm>
           <a:prstGeom prst="rect">
             <a:avLst/>
@@ -6364,7 +7506,7 @@
           <a:noFill/>
         </p:spPr>
         <p:txBody>
-          <a:bodyPr wrap="square" anchor="t">
+          <a:bodyPr wrap="square" anchor="ctr">
             <a:spAutoFit/>
           </a:bodyPr>
           <a:lstStyle/>
@@ -6375,13 +7517,346 @@
               </a:lnSpc>
             </a:pPr>
             <a:r>
-              <a:rPr sz="1300" b="0">
+              <a:rPr sz="1600" b="1">
+                <a:solidFill>
+                  <a:srgbClr val="00FF41"/>
+                </a:solidFill>
+                <a:latin typeface="Arial"/>
+              </a:rPr>
+              <a:t>▸  </a:t>
+            </a:r>
+            <a:r>
+              <a:rPr sz="1500" b="1">
+                <a:solidFill>
+                  <a:srgbClr val="F5F7FA"/>
+                </a:solidFill>
+                <a:latin typeface="Arial"/>
+              </a:rPr>
+              <a:t>This slide is yours. Add more slides behind it if you need them - keep your name on them.</a:t>
+            </a:r>
+          </a:p>
+        </p:txBody>
+      </p:sp>
+      <p:sp>
+        <p:nvSpPr>
+          <p:cNvPr id="8" name="TextBox 7"/>
+          <p:cNvSpPr txBox="1"/>
+          <p:nvPr/>
+        </p:nvSpPr>
+        <p:spPr>
+          <a:xfrm>
+            <a:off x="640080" y="6355080"/>
+            <a:ext cx="10972800" cy="365760"/>
+          </a:xfrm>
+          <a:prstGeom prst="rect">
+            <a:avLst/>
+          </a:prstGeom>
+          <a:noFill/>
+        </p:spPr>
+        <p:txBody>
+          <a:bodyPr wrap="square" anchor="t">
+            <a:spAutoFit/>
+          </a:bodyPr>
+          <a:lstStyle/>
+          <a:p>
+            <a:pPr algn="l">
+              <a:lnSpc>
+                <a:spcPct val="100000"/>
+              </a:lnSpc>
+            </a:pPr>
+            <a:r>
+              <a:rPr sz="1000" b="0">
                 <a:solidFill>
                   <a:srgbClr val="5A6474"/>
                 </a:solidFill>
                 <a:latin typeface="Courier New"/>
               </a:rPr>
-              <a:t>Real papers only — never invent a citation.</a:t>
+              <a:t>Value Verification · TECHIE 1121 · Cornell Tech · Tue Jul 28</a:t>
+            </a:r>
+          </a:p>
+        </p:txBody>
+      </p:sp>
+    </p:spTree>
+  </p:cSld>
+  <p:clrMapOvr>
+    <a:masterClrMapping/>
+  </p:clrMapOvr>
+</p:sld>
+</file>
+
+<file path=ppt/slides/slide9.xml><?xml version="1.0" encoding="utf-8"?>
+<p:sld xmlns:a="http://schemas.openxmlformats.org/drawingml/2006/main" xmlns:p="http://schemas.openxmlformats.org/presentationml/2006/main" xmlns:r="http://schemas.openxmlformats.org/officeDocument/2006/relationships">
+  <p:cSld>
+    <p:bg>
+      <p:bgPr>
+        <a:solidFill>
+          <a:srgbClr val="0B0E14"/>
+        </a:solidFill>
+        <a:effectLst/>
+      </p:bgPr>
+    </p:bg>
+    <p:spTree>
+      <p:nvGrpSpPr>
+        <p:cNvPr id="1" name=""/>
+        <p:cNvGrpSpPr/>
+        <p:nvPr/>
+      </p:nvGrpSpPr>
+      <p:grpSpPr/>
+      <p:sp>
+        <p:nvSpPr>
+          <p:cNvPr id="2" name="Rectangle 1"/>
+          <p:cNvSpPr/>
+          <p:nvPr/>
+        </p:nvSpPr>
+        <p:spPr>
+          <a:xfrm>
+            <a:off x="0" y="0"/>
+            <a:ext cx="256032" cy="6858000"/>
+          </a:xfrm>
+          <a:prstGeom prst="rect">
+            <a:avLst/>
+          </a:prstGeom>
+          <a:solidFill>
+            <a:srgbClr val="00FF41"/>
+          </a:solidFill>
+          <a:ln>
+            <a:noFill/>
+          </a:ln>
+          <a:effectLst/>
+        </p:spPr>
+        <p:style>
+          <a:lnRef idx="1">
+            <a:schemeClr val="accent1"/>
+          </a:lnRef>
+          <a:fillRef idx="3">
+            <a:schemeClr val="accent1"/>
+          </a:fillRef>
+          <a:effectRef idx="2">
+            <a:schemeClr val="accent1"/>
+          </a:effectRef>
+          <a:fontRef idx="minor">
+            <a:schemeClr val="lt1"/>
+          </a:fontRef>
+        </p:style>
+        <p:txBody>
+          <a:bodyPr rtlCol="0" anchor="ctr"/>
+          <a:lstStyle/>
+          <a:p>
+            <a:pPr algn="ctr"/>
+          </a:p>
+        </p:txBody>
+      </p:sp>
+      <p:sp>
+        <p:nvSpPr>
+          <p:cNvPr id="3" name="TextBox 2"/>
+          <p:cNvSpPr txBox="1"/>
+          <p:nvPr/>
+        </p:nvSpPr>
+        <p:spPr>
+          <a:xfrm>
+            <a:off x="822960" y="1417320"/>
+            <a:ext cx="2743200" cy="1097280"/>
+          </a:xfrm>
+          <a:prstGeom prst="rect">
+            <a:avLst/>
+          </a:prstGeom>
+          <a:noFill/>
+        </p:spPr>
+        <p:txBody>
+          <a:bodyPr wrap="square" anchor="t">
+            <a:spAutoFit/>
+          </a:bodyPr>
+          <a:lstStyle/>
+          <a:p>
+            <a:pPr algn="l">
+              <a:lnSpc>
+                <a:spcPct val="100000"/>
+              </a:lnSpc>
+            </a:pPr>
+            <a:r>
+              <a:rPr sz="6400" b="1">
+                <a:solidFill>
+                  <a:srgbClr val="00FF41"/>
+                </a:solidFill>
+                <a:latin typeface="Courier New"/>
+              </a:rPr>
+              <a:t>04</a:t>
+            </a:r>
+          </a:p>
+        </p:txBody>
+      </p:sp>
+      <p:sp>
+        <p:nvSpPr>
+          <p:cNvPr id="4" name="TextBox 3"/>
+          <p:cNvSpPr txBox="1"/>
+          <p:nvPr/>
+        </p:nvSpPr>
+        <p:spPr>
+          <a:xfrm>
+            <a:off x="841248" y="2487168"/>
+            <a:ext cx="10424160" cy="457200"/>
+          </a:xfrm>
+          <a:prstGeom prst="rect">
+            <a:avLst/>
+          </a:prstGeom>
+          <a:noFill/>
+        </p:spPr>
+        <p:txBody>
+          <a:bodyPr wrap="square" anchor="t">
+            <a:spAutoFit/>
+          </a:bodyPr>
+          <a:lstStyle/>
+          <a:p>
+            <a:pPr algn="l">
+              <a:lnSpc>
+                <a:spcPct val="100000"/>
+              </a:lnSpc>
+            </a:pPr>
+            <a:r>
+              <a:rPr sz="1500" b="1">
+                <a:solidFill>
+                  <a:srgbClr val="00FF41"/>
+                </a:solidFill>
+                <a:latin typeface="Courier New"/>
+              </a:rPr>
+              <a:t>PART 3 — OUTLOOK</a:t>
+            </a:r>
+          </a:p>
+        </p:txBody>
+      </p:sp>
+      <p:sp>
+        <p:nvSpPr>
+          <p:cNvPr id="5" name="TextBox 4"/>
+          <p:cNvSpPr txBox="1"/>
+          <p:nvPr/>
+        </p:nvSpPr>
+        <p:spPr>
+          <a:xfrm>
+            <a:off x="804672" y="2971800"/>
+            <a:ext cx="10607040" cy="1097280"/>
+          </a:xfrm>
+          <a:prstGeom prst="rect">
+            <a:avLst/>
+          </a:prstGeom>
+          <a:noFill/>
+        </p:spPr>
+        <p:txBody>
+          <a:bodyPr wrap="square" anchor="t">
+            <a:spAutoFit/>
+          </a:bodyPr>
+          <a:lstStyle/>
+          <a:p>
+            <a:pPr algn="l">
+              <a:lnSpc>
+                <a:spcPct val="103000"/>
+              </a:lnSpc>
+            </a:pPr>
+            <a:r>
+              <a:rPr sz="3800" b="1">
+                <a:solidFill>
+                  <a:srgbClr val="F5F7FA"/>
+                </a:solidFill>
+                <a:latin typeface="Arial"/>
+              </a:rPr>
+              <a:t>What related research has already found</a:t>
+            </a:r>
+          </a:p>
+        </p:txBody>
+      </p:sp>
+      <p:sp>
+        <p:nvSpPr>
+          <p:cNvPr id="6" name="TextBox 5"/>
+          <p:cNvSpPr txBox="1"/>
+          <p:nvPr/>
+        </p:nvSpPr>
+        <p:spPr>
+          <a:xfrm>
+            <a:off x="841248" y="4224528"/>
+            <a:ext cx="10424160" cy="1737360"/>
+          </a:xfrm>
+          <a:prstGeom prst="rect">
+            <a:avLst/>
+          </a:prstGeom>
+          <a:noFill/>
+        </p:spPr>
+        <p:txBody>
+          <a:bodyPr wrap="square" anchor="t">
+            <a:spAutoFit/>
+          </a:bodyPr>
+          <a:lstStyle/>
+          <a:p>
+            <a:pPr algn="l">
+              <a:lnSpc>
+                <a:spcPct val="128000"/>
+              </a:lnSpc>
+            </a:pPr>
+            <a:r>
+              <a:rPr sz="1700" b="1">
+                <a:solidFill>
+                  <a:srgbClr val="00FF41"/>
+                </a:solidFill>
+                <a:latin typeface="Arial"/>
+              </a:rPr>
+              <a:t>→  </a:t>
+            </a:r>
+            <a:r>
+              <a:rPr sz="1700" b="0">
+                <a:solidFill>
+                  <a:srgbClr val="8A94A6"/>
+                </a:solidFill>
+                <a:latin typeface="Arial"/>
+              </a:rPr>
+              <a:t>What have others tried in order to move this value?</a:t>
+            </a:r>
+          </a:p>
+          <a:p>
+            <a:pPr algn="l">
+              <a:lnSpc>
+                <a:spcPct val="128000"/>
+              </a:lnSpc>
+            </a:pPr>
+            <a:r>
+              <a:rPr sz="1700" b="1">
+                <a:solidFill>
+                  <a:srgbClr val="00FF41"/>
+                </a:solidFill>
+                <a:latin typeface="Arial"/>
+              </a:rPr>
+              <a:t>→  </a:t>
+            </a:r>
+            <a:r>
+              <a:rPr sz="1700" b="0">
+                <a:solidFill>
+                  <a:srgbClr val="8A94A6"/>
+                </a:solidFill>
+                <a:latin typeface="Arial"/>
+              </a:rPr>
+              <a:t>What worked — and what failed?</a:t>
+            </a:r>
+          </a:p>
+          <a:p>
+            <a:pPr algn="l">
+              <a:lnSpc>
+                <a:spcPct val="128000"/>
+              </a:lnSpc>
+            </a:pPr>
+            <a:r>
+              <a:rPr sz="1700" b="1">
+                <a:solidFill>
+                  <a:srgbClr val="00FF41"/>
+                </a:solidFill>
+                <a:latin typeface="Arial"/>
+              </a:rPr>
+              <a:t>→  </a:t>
+            </a:r>
+            <a:r>
+              <a:rPr sz="1700" b="0">
+                <a:solidFill>
+                  <a:srgbClr val="8A94A6"/>
+                </a:solidFill>
+                <a:latin typeface="Arial"/>
+              </a:rPr>
+              <a:t>2–3 REAL sources. Never invent a citation.</a:t>
             </a:r>
           </a:p>
         </p:txBody>

</xml_diff>

<commit_message>
Final week: a team's name IS the value it committed to
Team-deck cover now leads with 'The <Value> Team' (GitHub team name kept small for mapping).
Two teams have declared so far: security (Super Duper Amazing Team) and safety (Jamin's 2nd Team);
the other five show a 'name your team after your value' placeholder until Project 2 lands Monday.

Co-Authored-By: Claude Fable 5 <noreply@anthropic.com>
</commit_message>
<xml_diff>
--- a/slides/team-decks/Week3-Tue-chezborgar.pptx
+++ b/slides/team-decks/Week3-Tue-chezborgar.pptx
@@ -512,7 +512,7 @@
           <a:lstStyle/>
           <a:p>
             <a:r>
-              <a:t>Title slide. Confirm the value and the member list before presenting.</a:t>
+              <a:t>Team name = the value you carry into the final. Confirm the value + members before presenting.</a:t>
             </a:r>
           </a:p>
         </p:txBody>
@@ -4138,7 +4138,7 @@
         </p:nvSpPr>
         <p:spPr>
           <a:xfrm>
-            <a:off x="822960" y="1600200"/>
+            <a:off x="822960" y="1554480"/>
             <a:ext cx="10515600" cy="457200"/>
           </a:xfrm>
           <a:prstGeom prst="rect">
@@ -4177,7 +4177,7 @@
         </p:nvSpPr>
         <p:spPr>
           <a:xfrm>
-            <a:off x="804672" y="2148840"/>
+            <a:off x="804672" y="2103120"/>
             <a:ext cx="10607040" cy="1737360"/>
           </a:xfrm>
           <a:prstGeom prst="rect">
@@ -4199,11 +4199,11 @@
             <a:r>
               <a:rPr sz="4600" b="1">
                 <a:solidFill>
-                  <a:srgbClr val="F5F7FA"/>
-                </a:solidFill>
-                <a:latin typeface="Arial"/>
-              </a:rPr>
-              <a:t>Chezborgar</a:t>
+                  <a:srgbClr val="8A94A6"/>
+                </a:solidFill>
+                <a:latin typeface="Arial"/>
+              </a:rPr>
+              <a:t>[ name your team after your value ]</a:t>
             </a:r>
           </a:p>
         </p:txBody>
@@ -4255,8 +4255,8 @@
         </p:nvSpPr>
         <p:spPr>
           <a:xfrm>
-            <a:off x="841248" y="4526280"/>
-            <a:ext cx="10424160" cy="548640"/>
+            <a:off x="841248" y="4434840"/>
+            <a:ext cx="10424160" cy="457200"/>
           </a:xfrm>
           <a:prstGeom prst="rect">
             <a:avLst/>
@@ -4275,22 +4275,13 @@
               </a:lnSpc>
             </a:pPr>
             <a:r>
-              <a:rPr sz="1800" b="0">
-                <a:solidFill>
-                  <a:srgbClr val="F5F7FA"/>
-                </a:solidFill>
-                <a:latin typeface="Arial"/>
-              </a:rPr>
-              <a:t>The value we're carrying:  </a:t>
-            </a:r>
-            <a:r>
-              <a:rPr sz="1800" b="1">
-                <a:solidFill>
-                  <a:srgbClr val="8A94A6"/>
-                </a:solidFill>
-                <a:latin typeface="Arial"/>
-              </a:rPr>
-              <a:t>[ fill in ]</a:t>
+              <a:rPr sz="1300" b="0">
+                <a:solidFill>
+                  <a:srgbClr val="5A6474"/>
+                </a:solidFill>
+                <a:latin typeface="Courier New"/>
+              </a:rPr>
+              <a:t>GitHub team: Chezborgar</a:t>
             </a:r>
           </a:p>
         </p:txBody>

</xml_diff>

<commit_message>
Tuesday reshaped for the real time budget: no user tests today — RESEARCH the verification method + design interventions that moved the value, generative on design directions
- Team decks -> 6 groups (merged the two Justina repos). Sections: 01 operationalize · 02 how we'd
  verify (behavior=research, understanding/affect=quick student check) · 03 design interventions that
  moved the value (each member owns a named slide) · 04 our design directions (feeds Wednesday).
  Placeholders in [ ]. Values + Project 2 app prefilled per team.
- Lecture NOW YOU slide: research, don't run a test.
- Project 2 submissions online in the gallery (6 teams, all live, report linked + blurb).

Co-Authored-By: Claude Fable 5 <noreply@anthropic.com>
</commit_message>
<xml_diff>
--- a/slides/team-decks/Week3-Tue-chezborgar.pptx
+++ b/slides/team-decks/Week3-Tue-chezborgar.pptx
@@ -15,7 +15,6 @@
     <p:sldId id="263" r:id="rId15"/>
     <p:sldId id="264" r:id="rId16"/>
     <p:sldId id="265" r:id="rId17"/>
-    <p:sldId id="266" r:id="rId18"/>
   </p:sldIdLst>
   <p:sldSz cx="12191695" cy="6858000" type="screen4x3"/>
   <p:notesSz cx="6858000" cy="9144000"/>
@@ -792,7 +791,7 @@
           <a:lstStyle/>
           <a:p>
             <a:r>
-              <a:t>Emily Tai's individually graded section. Their reflection lives in their own lane on the team FigJam canvas.</a:t>
+              <a:t>Emily Tai's individual contribution: the design intervention they researched. Reflection lives in their own FigJam lane.</a:t>
             </a:r>
           </a:p>
         </p:txBody>
@@ -862,7 +861,7 @@
           <a:lstStyle/>
           <a:p>
             <a:r>
-              <a:t>Kylie Cheung's individually graded section. Their reflection lives in their own lane on the team FigJam canvas.</a:t>
+              <a:t>Kylie Cheung's individual contribution: the design intervention they researched. Reflection lives in their own FigJam lane.</a:t>
             </a:r>
           </a:p>
         </p:txBody>
@@ -932,7 +931,7 @@
           <a:lstStyle/>
           <a:p>
             <a:r>
-              <a:t>Aria Sharma's individually graded section. Their reflection lives in their own lane on the team FigJam canvas.</a:t>
+              <a:t>Aria Sharma's individual contribution: the design intervention they researched. Reflection lives in their own FigJam lane.</a:t>
             </a:r>
           </a:p>
         </p:txBody>
@@ -958,76 +957,6 @@
 </file>
 
 <file path=ppt/notesSlides/notesSlide8.xml><?xml version="1.0" encoding="utf-8"?>
-<p:notes xmlns:a="http://schemas.openxmlformats.org/drawingml/2006/main" xmlns:p="http://schemas.openxmlformats.org/presentationml/2006/main" xmlns:r="http://schemas.openxmlformats.org/officeDocument/2006/relationships">
-  <p:cSld>
-    <p:spTree>
-      <p:nvGrpSpPr>
-        <p:cNvPr id="1" name=""/>
-        <p:cNvGrpSpPr/>
-        <p:nvPr/>
-      </p:nvGrpSpPr>
-      <p:grpSpPr>
-        <a:xfrm>
-          <a:off x="0" y="0"/>
-          <a:ext cx="0" cy="0"/>
-          <a:chOff x="0" y="0"/>
-          <a:chExt cx="0" cy="0"/>
-        </a:xfrm>
-      </p:grpSpPr>
-      <p:sp>
-        <p:nvSpPr>
-          <p:cNvPr id="2" name="Slide Image Placeholder 1"/>
-          <p:cNvSpPr>
-            <a:spLocks noGrp="1"/>
-          </p:cNvSpPr>
-          <p:nvPr>
-            <p:ph type="sldImg" idx="2"/>
-          </p:nvPr>
-        </p:nvSpPr>
-        <p:spPr/>
-      </p:sp>
-      <p:sp>
-        <p:nvSpPr>
-          <p:cNvPr id="3" name="Notes Placeholder 2"/>
-          <p:cNvSpPr>
-            <a:spLocks noGrp="1"/>
-          </p:cNvSpPr>
-          <p:nvPr>
-            <p:ph type="body" idx="3" sz="quarter"/>
-          </p:nvPr>
-        </p:nvSpPr>
-        <p:spPr/>
-        <p:txBody>
-          <a:bodyPr/>
-          <a:lstStyle/>
-          <a:p>
-            <a:r>
-              <a:t>Section header — the team's own slides go after this one.</a:t>
-            </a:r>
-          </a:p>
-        </p:txBody>
-      </p:sp>
-      <p:sp>
-        <p:nvSpPr>
-          <p:cNvPr id="4" name="Slide Number Placeholder 3"/>
-          <p:cNvSpPr>
-            <a:spLocks noGrp="1"/>
-          </p:cNvSpPr>
-          <p:nvPr>
-            <p:ph type="sldNum" idx="5" sz="quarter"/>
-          </p:nvPr>
-        </p:nvSpPr>
-        <p:spPr/>
-      </p:sp>
-    </p:spTree>
-  </p:cSld>
-  <p:clrMapOvr>
-    <a:masterClrMapping/>
-  </p:clrMapOvr>
-</p:notes>
-</file>
-
-<file path=ppt/notesSlides/notesSlide9.xml><?xml version="1.0" encoding="utf-8"?>
 <p:notes xmlns:a="http://schemas.openxmlformats.org/drawingml/2006/main" xmlns:p="http://schemas.openxmlformats.org/presentationml/2006/main" xmlns:r="http://schemas.openxmlformats.org/officeDocument/2006/relationships">
   <p:cSld>
     <p:spTree>
@@ -4401,330 +4330,6 @@
       <p:grpSpPr/>
       <p:sp>
         <p:nvSpPr>
-          <p:cNvPr id="2" name="Rectangle 1"/>
-          <p:cNvSpPr/>
-          <p:nvPr/>
-        </p:nvSpPr>
-        <p:spPr>
-          <a:xfrm>
-            <a:off x="0" y="0"/>
-            <a:ext cx="256032" cy="6858000"/>
-          </a:xfrm>
-          <a:prstGeom prst="rect">
-            <a:avLst/>
-          </a:prstGeom>
-          <a:solidFill>
-            <a:srgbClr val="00FF41"/>
-          </a:solidFill>
-          <a:ln>
-            <a:noFill/>
-          </a:ln>
-          <a:effectLst/>
-        </p:spPr>
-        <p:style>
-          <a:lnRef idx="1">
-            <a:schemeClr val="accent1"/>
-          </a:lnRef>
-          <a:fillRef idx="3">
-            <a:schemeClr val="accent1"/>
-          </a:fillRef>
-          <a:effectRef idx="2">
-            <a:schemeClr val="accent1"/>
-          </a:effectRef>
-          <a:fontRef idx="minor">
-            <a:schemeClr val="lt1"/>
-          </a:fontRef>
-        </p:style>
-        <p:txBody>
-          <a:bodyPr rtlCol="0" anchor="ctr"/>
-          <a:lstStyle/>
-          <a:p>
-            <a:pPr algn="ctr"/>
-          </a:p>
-        </p:txBody>
-      </p:sp>
-      <p:sp>
-        <p:nvSpPr>
-          <p:cNvPr id="3" name="TextBox 2"/>
-          <p:cNvSpPr txBox="1"/>
-          <p:nvPr/>
-        </p:nvSpPr>
-        <p:spPr>
-          <a:xfrm>
-            <a:off x="822960" y="1417320"/>
-            <a:ext cx="2743200" cy="1097280"/>
-          </a:xfrm>
-          <a:prstGeom prst="rect">
-            <a:avLst/>
-          </a:prstGeom>
-          <a:noFill/>
-        </p:spPr>
-        <p:txBody>
-          <a:bodyPr wrap="square" anchor="t">
-            <a:spAutoFit/>
-          </a:bodyPr>
-          <a:lstStyle/>
-          <a:p>
-            <a:pPr algn="l">
-              <a:lnSpc>
-                <a:spcPct val="100000"/>
-              </a:lnSpc>
-            </a:pPr>
-            <a:r>
-              <a:rPr sz="6400" b="1">
-                <a:solidFill>
-                  <a:srgbClr val="00FF41"/>
-                </a:solidFill>
-                <a:latin typeface="Courier New"/>
-              </a:rPr>
-              <a:t>05</a:t>
-            </a:r>
-          </a:p>
-        </p:txBody>
-      </p:sp>
-      <p:sp>
-        <p:nvSpPr>
-          <p:cNvPr id="4" name="TextBox 3"/>
-          <p:cNvSpPr txBox="1"/>
-          <p:nvPr/>
-        </p:nvSpPr>
-        <p:spPr>
-          <a:xfrm>
-            <a:off x="841248" y="2487168"/>
-            <a:ext cx="10424160" cy="457200"/>
-          </a:xfrm>
-          <a:prstGeom prst="rect">
-            <a:avLst/>
-          </a:prstGeom>
-          <a:noFill/>
-        </p:spPr>
-        <p:txBody>
-          <a:bodyPr wrap="square" anchor="t">
-            <a:spAutoFit/>
-          </a:bodyPr>
-          <a:lstStyle/>
-          <a:p>
-            <a:pPr algn="l">
-              <a:lnSpc>
-                <a:spcPct val="100000"/>
-              </a:lnSpc>
-            </a:pPr>
-            <a:r>
-              <a:rPr sz="1500" b="1">
-                <a:solidFill>
-                  <a:srgbClr val="00FF41"/>
-                </a:solidFill>
-                <a:latin typeface="Courier New"/>
-              </a:rPr>
-              <a:t>SO WHAT</a:t>
-            </a:r>
-          </a:p>
-        </p:txBody>
-      </p:sp>
-      <p:sp>
-        <p:nvSpPr>
-          <p:cNvPr id="5" name="TextBox 4"/>
-          <p:cNvSpPr txBox="1"/>
-          <p:nvPr/>
-        </p:nvSpPr>
-        <p:spPr>
-          <a:xfrm>
-            <a:off x="804672" y="2971800"/>
-            <a:ext cx="10607040" cy="1097280"/>
-          </a:xfrm>
-          <a:prstGeom prst="rect">
-            <a:avLst/>
-          </a:prstGeom>
-          <a:noFill/>
-        </p:spPr>
-        <p:txBody>
-          <a:bodyPr wrap="square" anchor="t">
-            <a:spAutoFit/>
-          </a:bodyPr>
-          <a:lstStyle/>
-          <a:p>
-            <a:pPr algn="l">
-              <a:lnSpc>
-                <a:spcPct val="103000"/>
-              </a:lnSpc>
-            </a:pPr>
-            <a:r>
-              <a:rPr sz="3800" b="1">
-                <a:solidFill>
-                  <a:srgbClr val="F5F7FA"/>
-                </a:solidFill>
-                <a:latin typeface="Arial"/>
-              </a:rPr>
-              <a:t>Our next design brief</a:t>
-            </a:r>
-          </a:p>
-        </p:txBody>
-      </p:sp>
-      <p:sp>
-        <p:nvSpPr>
-          <p:cNvPr id="6" name="TextBox 5"/>
-          <p:cNvSpPr txBox="1"/>
-          <p:nvPr/>
-        </p:nvSpPr>
-        <p:spPr>
-          <a:xfrm>
-            <a:off x="841248" y="4224528"/>
-            <a:ext cx="10424160" cy="1737360"/>
-          </a:xfrm>
-          <a:prstGeom prst="rect">
-            <a:avLst/>
-          </a:prstGeom>
-          <a:noFill/>
-        </p:spPr>
-        <p:txBody>
-          <a:bodyPr wrap="square" anchor="t">
-            <a:spAutoFit/>
-          </a:bodyPr>
-          <a:lstStyle/>
-          <a:p>
-            <a:pPr algn="l">
-              <a:lnSpc>
-                <a:spcPct val="128000"/>
-              </a:lnSpc>
-            </a:pPr>
-            <a:r>
-              <a:rPr sz="1700" b="1">
-                <a:solidFill>
-                  <a:srgbClr val="00FF41"/>
-                </a:solidFill>
-                <a:latin typeface="Arial"/>
-              </a:rPr>
-              <a:t>→  </a:t>
-            </a:r>
-            <a:r>
-              <a:rPr sz="1700" b="0">
-                <a:solidFill>
-                  <a:srgbClr val="8A94A6"/>
-                </a:solidFill>
-                <a:latin typeface="Arial"/>
-              </a:rPr>
-              <a:t>Verification opens the next design - it doesn't just grade this one.</a:t>
-            </a:r>
-          </a:p>
-          <a:p>
-            <a:pPr algn="l">
-              <a:lnSpc>
-                <a:spcPct val="128000"/>
-              </a:lnSpc>
-            </a:pPr>
-            <a:r>
-              <a:rPr sz="1700" b="1">
-                <a:solidFill>
-                  <a:srgbClr val="00FF41"/>
-                </a:solidFill>
-                <a:latin typeface="Arial"/>
-              </a:rPr>
-              <a:t>→  </a:t>
-            </a:r>
-            <a:r>
-              <a:rPr sz="1700" b="0">
-                <a:solidFill>
-                  <a:srgbClr val="8A94A6"/>
-                </a:solidFill>
-                <a:latin typeface="Arial"/>
-              </a:rPr>
-              <a:t>What OTHER design could actually achieve this value?</a:t>
-            </a:r>
-          </a:p>
-          <a:p>
-            <a:pPr algn="l">
-              <a:lnSpc>
-                <a:spcPct val="128000"/>
-              </a:lnSpc>
-            </a:pPr>
-            <a:r>
-              <a:rPr sz="1700" b="1">
-                <a:solidFill>
-                  <a:srgbClr val="00FF41"/>
-                </a:solidFill>
-                <a:latin typeface="Arial"/>
-              </a:rPr>
-              <a:t>→  </a:t>
-            </a:r>
-            <a:r>
-              <a:rPr sz="1700" b="0">
-                <a:solidFill>
-                  <a:srgbClr val="8A94A6"/>
-                </a:solidFill>
-                <a:latin typeface="Arial"/>
-              </a:rPr>
-              <a:t>What should the next cycle discover? (You carry this into Wednesday.)</a:t>
-            </a:r>
-          </a:p>
-        </p:txBody>
-      </p:sp>
-      <p:sp>
-        <p:nvSpPr>
-          <p:cNvPr id="7" name="TextBox 6"/>
-          <p:cNvSpPr txBox="1"/>
-          <p:nvPr/>
-        </p:nvSpPr>
-        <p:spPr>
-          <a:xfrm>
-            <a:off x="640080" y="6355080"/>
-            <a:ext cx="10972800" cy="365760"/>
-          </a:xfrm>
-          <a:prstGeom prst="rect">
-            <a:avLst/>
-          </a:prstGeom>
-          <a:noFill/>
-        </p:spPr>
-        <p:txBody>
-          <a:bodyPr wrap="square" anchor="t">
-            <a:spAutoFit/>
-          </a:bodyPr>
-          <a:lstStyle/>
-          <a:p>
-            <a:pPr algn="l">
-              <a:lnSpc>
-                <a:spcPct val="100000"/>
-              </a:lnSpc>
-            </a:pPr>
-            <a:r>
-              <a:rPr sz="1000" b="0">
-                <a:solidFill>
-                  <a:srgbClr val="5A6474"/>
-                </a:solidFill>
-                <a:latin typeface="Courier New"/>
-              </a:rPr>
-              <a:t>Value Verification · TECHIE 1121 · Cornell Tech · Tue Jul 28</a:t>
-            </a:r>
-          </a:p>
-        </p:txBody>
-      </p:sp>
-    </p:spTree>
-  </p:cSld>
-  <p:clrMapOvr>
-    <a:masterClrMapping/>
-  </p:clrMapOvr>
-</p:sld>
-</file>
-
-<file path=ppt/slides/slide11.xml><?xml version="1.0" encoding="utf-8"?>
-<p:sld xmlns:a="http://schemas.openxmlformats.org/drawingml/2006/main" xmlns:p="http://schemas.openxmlformats.org/presentationml/2006/main" xmlns:r="http://schemas.openxmlformats.org/officeDocument/2006/relationships">
-  <p:cSld>
-    <p:bg>
-      <p:bgPr>
-        <a:solidFill>
-          <a:srgbClr val="0B0E14"/>
-        </a:solidFill>
-        <a:effectLst/>
-      </p:bgPr>
-    </p:bg>
-    <p:spTree>
-      <p:nvGrpSpPr>
-        <p:cNvPr id="1" name=""/>
-        <p:cNvGrpSpPr/>
-        <p:nvPr/>
-      </p:nvGrpSpPr>
-      <p:grpSpPr/>
-      <p:sp>
-        <p:nvSpPr>
           <p:cNvPr id="2" name="TextBox 1"/>
           <p:cNvSpPr txBox="1"/>
           <p:nvPr/>
@@ -5237,7 +4842,7 @@
                 </a:solidFill>
                 <a:latin typeface="Arial"/>
               </a:rPr>
-              <a:t>Five section headers follow — they are the spine of your talk.</a:t>
+              <a:t>Four section headers follow — they are the spine of your talk.</a:t>
             </a:r>
           </a:p>
           <a:p>
@@ -5262,7 +4867,7 @@
                 </a:solidFill>
                 <a:latin typeface="Arial"/>
               </a:rPr>
-              <a:t>Sections 01, 02, 04, 05 are the TEAM's. Section 03 has one named slide per person — that one is graded individually.</a:t>
+              <a:t>Sections 01, 02, 04 are the TEAM's. Section 03 has one named slide per person — your individual contribution.</a:t>
             </a:r>
           </a:p>
           <a:p>
@@ -5312,7 +4917,7 @@
                 </a:solidFill>
                 <a:latin typeface="Arial"/>
               </a:rPr>
-              <a:t>Evidence beats assertion: screenshots, numbers, quotes from what you actually observed.</a:t>
+              <a:t>No time to run full tests today - so RESEARCH the method, and what interventions have actually moved this value.</a:t>
             </a:r>
           </a:p>
           <a:p>
@@ -5613,7 +5218,7 @@
                 </a:solidFill>
                 <a:latin typeface="Arial"/>
               </a:rPr>
-              <a:t>What we claimed — and how we operationalize it</a:t>
+              <a:t>Discovery - operationalize the value</a:t>
             </a:r>
           </a:p>
         </p:txBody>
@@ -5661,7 +5266,7 @@
                 </a:solidFill>
                 <a:latin typeface="Arial"/>
               </a:rPr>
-              <a:t>Our app, in one line — and the value it claims.</a:t>
+              <a:t>[ our app, in one line ]  -  and the value it claims.</a:t>
             </a:r>
           </a:p>
           <a:p>
@@ -5686,7 +5291,7 @@
                 </a:solidFill>
                 <a:latin typeface="Arial"/>
               </a:rPr>
-              <a:t>How do we operationalize / define the value? (e.g. privacy as control vs. security vs. contextual integrity)</a:t>
+              <a:t>How do we operationalize / define the value?  (privacy as control vs. security vs. contextual integrity)</a:t>
             </a:r>
           </a:p>
           <a:p>
@@ -5711,7 +5316,7 @@
                 </a:solidFill>
                 <a:latin typeface="Arial"/>
               </a:rPr>
-              <a:t>If it's present, users will DO ___ / UNDERSTAND ___ / FEEL ___.</a:t>
+              <a:t>If it is present, users will DO [ ___ ] / UNDERSTAND [ ___ ] / FEEL [ ___ ].</a:t>
             </a:r>
           </a:p>
         </p:txBody>
@@ -5898,7 +5503,7 @@
                 </a:solidFill>
                 <a:latin typeface="Courier New"/>
               </a:rPr>
-              <a:t>PART 1 — WAYS TO VERIFY</a:t>
+              <a:t>HOW WOULD WE VERIFY IT?</a:t>
             </a:r>
           </a:p>
         </p:txBody>
@@ -5937,7 +5542,7 @@
                 </a:solidFill>
                 <a:latin typeface="Arial"/>
               </a:rPr>
-              <a:t>How can this value be verified at all?</a:t>
+              <a:t>Pick a method per lens - we won't run them all today</a:t>
             </a:r>
           </a:p>
         </p:txBody>
@@ -5985,7 +5590,7 @@
                 </a:solidFill>
                 <a:latin typeface="Arial"/>
               </a:rPr>
-              <a:t>How have others measured this value? (Google Scholar + its AI search)</a:t>
+              <a:t>BEHAVIOR - do users ACT differently?  -&gt;  hard to test in class, so we RESEARCH it: [ method + what studies show ].</a:t>
             </a:r>
           </a:p>
           <a:p>
@@ -6010,7 +5615,7 @@
                 </a:solidFill>
                 <a:latin typeface="Arial"/>
               </a:rPr>
-              <a:t>Which method did we choose — and why does our reading demand it?</a:t>
+              <a:t>UNDERSTANDING - do they GRASP the value?  -&gt;  a quick check with fellow students is possible: [ method ].</a:t>
             </a:r>
           </a:p>
           <a:p>
@@ -6035,7 +5640,7 @@
                 </a:solidFill>
                 <a:latin typeface="Arial"/>
               </a:rPr>
-              <a:t>The instrument we borrowed: UEQ · an HRI/SDT scale · the slop detector · a task design.</a:t>
+              <a:t>AFFECT - do they FEEL differently?  -&gt;  a quick check with fellow students is possible: [ method ].</a:t>
             </a:r>
           </a:p>
         </p:txBody>
@@ -6222,7 +5827,7 @@
                 </a:solidFill>
                 <a:latin typeface="Courier New"/>
               </a:rPr>
-              <a:t>PART 2 — WHAT WE FOUND</a:t>
+              <a:t>DESIGN INTERVENTIONS THAT MOVED THIS VALUE</a:t>
             </a:r>
           </a:p>
         </p:txBody>
@@ -6261,7 +5866,7 @@
                 </a:solidFill>
                 <a:latin typeface="Arial"/>
               </a:rPr>
-              <a:t>Insights from our own verification</a:t>
+              <a:t>Research - what has actually worked? (each member owns a slide)</a:t>
             </a:r>
           </a:p>
         </p:txBody>
@@ -6309,7 +5914,7 @@
                 </a:solidFill>
                 <a:latin typeface="Arial"/>
               </a:rPr>
-              <a:t>Each team member presents their OWN slide — the named slides that follow.</a:t>
+              <a:t>Each member presents their OWN researched intervention - the named slides that follow.</a:t>
             </a:r>
           </a:p>
           <a:p>
@@ -6334,7 +5939,7 @@
                 </a:solidFill>
                 <a:latin typeface="Arial"/>
               </a:rPr>
-              <a:t>What WORKS and what does NOT — with evidence. An evidenced 'it doesn't' beats a hopeful 'it does'.</a:t>
+              <a:t>A real design intervention tried for this value, and its result: worked / mixed / failed.</a:t>
             </a:r>
           </a:p>
           <a:p>
@@ -6359,7 +5964,7 @@
                 </a:solidFill>
                 <a:latin typeface="Arial"/>
               </a:rPr>
-              <a:t>Across the lenses: behavior · understanding · affect — and which lenses did NOT fit this value.</a:t>
+              <a:t>Real sources only - never invent a citation.</a:t>
             </a:r>
           </a:p>
         </p:txBody>
@@ -6463,7 +6068,7 @@
                 </a:solidFill>
                 <a:latin typeface="Courier New"/>
               </a:rPr>
-              <a:t>03.1  ·  YOUR SECTION (graded individually)</a:t>
+              <a:t>03.1  ·  YOUR SLIDE (your individual contribution)</a:t>
             </a:r>
           </a:p>
         </p:txBody>
@@ -6594,7 +6199,7 @@
                 </a:solidFill>
                 <a:latin typeface="Arial"/>
               </a:rPr>
-              <a:t>The lens + method I ran, and why our reading demanded it</a:t>
+              <a:t>A design intervention someone tried to move THIS value - [ what they did ]</a:t>
             </a:r>
           </a:p>
           <a:p>
@@ -6619,7 +6224,7 @@
                 </a:solidFill>
                 <a:latin typeface="Arial"/>
               </a:rPr>
-              <a:t>My evidence - what I actually observed or measured</a:t>
+              <a:t>The result - [ worked / mixed / failed ] - and the real source [ author, year ]</a:t>
             </a:r>
           </a:p>
           <a:p>
@@ -6644,7 +6249,7 @@
                 </a:solidFill>
                 <a:latin typeface="Arial"/>
               </a:rPr>
-              <a:t>What this says WORKS - and what does NOT</a:t>
+              <a:t>How you'd test it - [ method ]  (behavior = research it; understanding/affect = quick student check)</a:t>
             </a:r>
           </a:p>
           <a:p>
@@ -6669,7 +6274,7 @@
                 </a:solidFill>
                 <a:latin typeface="Arial"/>
               </a:rPr>
-              <a:t>The paper I found (real citation) and what it changes</a:t>
+              <a:t>Does it support or challenge our design direction? - [ ___ ]</a:t>
             </a:r>
           </a:p>
         </p:txBody>
@@ -6867,7 +6472,7 @@
                 </a:solidFill>
                 <a:latin typeface="Courier New"/>
               </a:rPr>
-              <a:t>03.2  ·  YOUR SECTION (graded individually)</a:t>
+              <a:t>03.2  ·  YOUR SLIDE (your individual contribution)</a:t>
             </a:r>
           </a:p>
         </p:txBody>
@@ -6998,7 +6603,7 @@
                 </a:solidFill>
                 <a:latin typeface="Arial"/>
               </a:rPr>
-              <a:t>The lens + method I ran, and why our reading demanded it</a:t>
+              <a:t>A design intervention someone tried to move THIS value - [ what they did ]</a:t>
             </a:r>
           </a:p>
           <a:p>
@@ -7023,7 +6628,7 @@
                 </a:solidFill>
                 <a:latin typeface="Arial"/>
               </a:rPr>
-              <a:t>My evidence - what I actually observed or measured</a:t>
+              <a:t>The result - [ worked / mixed / failed ] - and the real source [ author, year ]</a:t>
             </a:r>
           </a:p>
           <a:p>
@@ -7048,7 +6653,7 @@
                 </a:solidFill>
                 <a:latin typeface="Arial"/>
               </a:rPr>
-              <a:t>What this says WORKS - and what does NOT</a:t>
+              <a:t>How you'd test it - [ method ]  (behavior = research it; understanding/affect = quick student check)</a:t>
             </a:r>
           </a:p>
           <a:p>
@@ -7073,7 +6678,7 @@
                 </a:solidFill>
                 <a:latin typeface="Arial"/>
               </a:rPr>
-              <a:t>The paper I found (real citation) and what it changes</a:t>
+              <a:t>Does it support or challenge our design direction? - [ ___ ]</a:t>
             </a:r>
           </a:p>
         </p:txBody>
@@ -7271,7 +6876,7 @@
                 </a:solidFill>
                 <a:latin typeface="Courier New"/>
               </a:rPr>
-              <a:t>03.3  ·  YOUR SECTION (graded individually)</a:t>
+              <a:t>03.3  ·  YOUR SLIDE (your individual contribution)</a:t>
             </a:r>
           </a:p>
         </p:txBody>
@@ -7402,7 +7007,7 @@
                 </a:solidFill>
                 <a:latin typeface="Arial"/>
               </a:rPr>
-              <a:t>The lens + method I ran, and why our reading demanded it</a:t>
+              <a:t>A design intervention someone tried to move THIS value - [ what they did ]</a:t>
             </a:r>
           </a:p>
           <a:p>
@@ -7427,7 +7032,7 @@
                 </a:solidFill>
                 <a:latin typeface="Arial"/>
               </a:rPr>
-              <a:t>My evidence - what I actually observed or measured</a:t>
+              <a:t>The result - [ worked / mixed / failed ] - and the real source [ author, year ]</a:t>
             </a:r>
           </a:p>
           <a:p>
@@ -7452,7 +7057,7 @@
                 </a:solidFill>
                 <a:latin typeface="Arial"/>
               </a:rPr>
-              <a:t>What this says WORKS - and what does NOT</a:t>
+              <a:t>How you'd test it - [ method ]  (behavior = research it; understanding/affect = quick student check)</a:t>
             </a:r>
           </a:p>
           <a:p>
@@ -7477,7 +7082,7 @@
                 </a:solidFill>
                 <a:latin typeface="Arial"/>
               </a:rPr>
-              <a:t>The paper I found (real citation) and what it changes</a:t>
+              <a:t>Does it support or challenge our design direction? - [ ___ ]</a:t>
             </a:r>
           </a:p>
         </p:txBody>
@@ -7758,7 +7363,7 @@
                 </a:solidFill>
                 <a:latin typeface="Courier New"/>
               </a:rPr>
-              <a:t>PART 3 — OUTLOOK</a:t>
+              <a:t>OUR DESIGN DIRECTIONS</a:t>
             </a:r>
           </a:p>
         </p:txBody>
@@ -7797,7 +7402,7 @@
                 </a:solidFill>
                 <a:latin typeface="Arial"/>
               </a:rPr>
-              <a:t>What related research has already found</a:t>
+              <a:t>Generative - where the evidence points (carry into Wednesday)</a:t>
             </a:r>
           </a:p>
         </p:txBody>
@@ -7845,7 +7450,7 @@
                 </a:solidFill>
                 <a:latin typeface="Arial"/>
               </a:rPr>
-              <a:t>What have others tried in order to move this value?</a:t>
+              <a:t>2-3 design directions our research points to.</a:t>
             </a:r>
           </a:p>
           <a:p>
@@ -7870,7 +7475,7 @@
                 </a:solidFill>
                 <a:latin typeface="Arial"/>
               </a:rPr>
-              <a:t>What worked — and what failed?</a:t>
+              <a:t>Which one has the strongest evidence behind it?</a:t>
             </a:r>
           </a:p>
           <a:p>
@@ -7895,7 +7500,7 @@
                 </a:solidFill>
                 <a:latin typeface="Arial"/>
               </a:rPr>
-              <a:t>2–3 REAL sources. Never invent a citation.</a:t>
+              <a:t>What would we still need to verify - and how?</a:t>
             </a:r>
           </a:p>
         </p:txBody>

</xml_diff>